<commit_message>
Restyle the free-lessons deck to official 50+ TechBridge colors.
Use the public-site palette only: navy, indigo, orange, cyan, green,
ice, mist, and slate. Drop cream and off-brand gray.

Co-authored-by: 1Profmac <1Profmac@users.noreply.github.com>
</commit_message>
<xml_diff>
--- a/lessons/slides/50plus-techbridge-free-lessons.pptx
+++ b/lessons/slides/50plus-techbridge-free-lessons.pptx
@@ -4981,6 +4981,92 @@
         <p:spPr>
           <a:xfrm>
             <a:off x="0" y="0"/>
+            <a:ext cx="4206240" cy="6858000"/>
+          </a:xfrm>
+          <a:prstGeom prst="rect">
+            <a:avLst/>
+          </a:prstGeom>
+          <a:solidFill>
+            <a:srgbClr val="2B315F"/>
+          </a:solidFill>
+          <a:ln>
+            <a:noFill/>
+          </a:ln>
+        </p:spPr>
+        <p:style>
+          <a:lnRef idx="1">
+            <a:schemeClr val="accent1"/>
+          </a:lnRef>
+          <a:fillRef idx="3">
+            <a:schemeClr val="accent1"/>
+          </a:fillRef>
+          <a:effectRef idx="2">
+            <a:schemeClr val="accent1"/>
+          </a:effectRef>
+          <a:fontRef idx="minor">
+            <a:schemeClr val="lt1"/>
+          </a:fontRef>
+        </p:style>
+        <p:txBody>
+          <a:bodyPr rtlCol="0" anchor="ctr"/>
+          <a:lstStyle/>
+          <a:p>
+            <a:pPr algn="ctr"/>
+          </a:p>
+        </p:txBody>
+      </p:sp>
+      <p:sp>
+        <p:nvSpPr>
+          <p:cNvPr id="4" name="Rectangle 3"/>
+          <p:cNvSpPr/>
+          <p:nvPr/>
+        </p:nvSpPr>
+        <p:spPr>
+          <a:xfrm>
+            <a:off x="0" y="6784848"/>
+            <a:ext cx="12191695" cy="73152"/>
+          </a:xfrm>
+          <a:prstGeom prst="rect">
+            <a:avLst/>
+          </a:prstGeom>
+          <a:solidFill>
+            <a:srgbClr val="00A3DC"/>
+          </a:solidFill>
+          <a:ln>
+            <a:noFill/>
+          </a:ln>
+        </p:spPr>
+        <p:style>
+          <a:lnRef idx="1">
+            <a:schemeClr val="accent1"/>
+          </a:lnRef>
+          <a:fillRef idx="3">
+            <a:schemeClr val="accent1"/>
+          </a:fillRef>
+          <a:effectRef idx="2">
+            <a:schemeClr val="accent1"/>
+          </a:effectRef>
+          <a:fontRef idx="minor">
+            <a:schemeClr val="lt1"/>
+          </a:fontRef>
+        </p:style>
+        <p:txBody>
+          <a:bodyPr rtlCol="0" anchor="ctr"/>
+          <a:lstStyle/>
+          <a:p>
+            <a:pPr algn="ctr"/>
+          </a:p>
+        </p:txBody>
+      </p:sp>
+      <p:sp>
+        <p:nvSpPr>
+          <p:cNvPr id="5" name="Rectangle 4"/>
+          <p:cNvSpPr/>
+          <p:nvPr/>
+        </p:nvSpPr>
+        <p:spPr>
+          <a:xfrm>
+            <a:off x="0" y="0"/>
             <a:ext cx="201168" cy="6858000"/>
           </a:xfrm>
           <a:prstGeom prst="rect">
@@ -5017,14 +5103,100 @@
       </p:sp>
       <p:sp>
         <p:nvSpPr>
-          <p:cNvPr id="4" name="TextBox 3"/>
+          <p:cNvPr id="6" name="Rectangle 5"/>
+          <p:cNvSpPr/>
+          <p:nvPr/>
+        </p:nvSpPr>
+        <p:spPr>
+          <a:xfrm>
+            <a:off x="640080" y="411480"/>
+            <a:ext cx="566928" cy="566928"/>
+          </a:xfrm>
+          <a:prstGeom prst="rect">
+            <a:avLst/>
+          </a:prstGeom>
+          <a:solidFill>
+            <a:srgbClr val="083655"/>
+          </a:solidFill>
+          <a:ln>
+            <a:noFill/>
+          </a:ln>
+        </p:spPr>
+        <p:style>
+          <a:lnRef idx="1">
+            <a:schemeClr val="accent1"/>
+          </a:lnRef>
+          <a:fillRef idx="3">
+            <a:schemeClr val="accent1"/>
+          </a:fillRef>
+          <a:effectRef idx="2">
+            <a:schemeClr val="accent1"/>
+          </a:effectRef>
+          <a:fontRef idx="minor">
+            <a:schemeClr val="lt1"/>
+          </a:fontRef>
+        </p:style>
+        <p:txBody>
+          <a:bodyPr rtlCol="0" anchor="ctr"/>
+          <a:lstStyle/>
+          <a:p>
+            <a:pPr algn="ctr"/>
+          </a:p>
+        </p:txBody>
+      </p:sp>
+      <p:sp>
+        <p:nvSpPr>
+          <p:cNvPr id="7" name="Rectangle 6"/>
+          <p:cNvSpPr/>
+          <p:nvPr/>
+        </p:nvSpPr>
+        <p:spPr>
+          <a:xfrm>
+            <a:off x="895197" y="411480"/>
+            <a:ext cx="311810" cy="566928"/>
+          </a:xfrm>
+          <a:prstGeom prst="rect">
+            <a:avLst/>
+          </a:prstGeom>
+          <a:solidFill>
+            <a:srgbClr val="E2752E"/>
+          </a:solidFill>
+          <a:ln>
+            <a:noFill/>
+          </a:ln>
+        </p:spPr>
+        <p:style>
+          <a:lnRef idx="1">
+            <a:schemeClr val="accent1"/>
+          </a:lnRef>
+          <a:fillRef idx="3">
+            <a:schemeClr val="accent1"/>
+          </a:fillRef>
+          <a:effectRef idx="2">
+            <a:schemeClr val="accent1"/>
+          </a:effectRef>
+          <a:fontRef idx="minor">
+            <a:schemeClr val="lt1"/>
+          </a:fontRef>
+        </p:style>
+        <p:txBody>
+          <a:bodyPr rtlCol="0" anchor="ctr"/>
+          <a:lstStyle/>
+          <a:p>
+            <a:pPr algn="ctr"/>
+          </a:p>
+        </p:txBody>
+      </p:sp>
+      <p:sp>
+        <p:nvSpPr>
+          <p:cNvPr id="8" name="TextBox 7"/>
           <p:cNvSpPr txBox="1"/>
           <p:nvPr/>
         </p:nvSpPr>
         <p:spPr>
           <a:xfrm>
-            <a:off x="640080" y="1371600"/>
-            <a:ext cx="10972800" cy="365760"/>
+            <a:off x="640080" y="479511"/>
+            <a:ext cx="566928" cy="453542"/>
           </a:xfrm>
           <a:prstGeom prst="rect">
             <a:avLst/>
@@ -5037,33 +5209,33 @@
           </a:bodyPr>
           <a:lstStyle/>
           <a:p>
-            <a:pPr algn="l">
-              <a:spcAft>
-                <a:spcPts val="800"/>
-              </a:spcAft>
-            </a:pPr>
-            <a:r>
-              <a:rPr sz="1600" b="1">
-                <a:solidFill>
-                  <a:srgbClr val="E2752E"/>
-                </a:solidFill>
-                <a:latin typeface="Arial"/>
-              </a:rPr>
-              <a:t>FREE LESSONS  ·  1 OF 3 SERIES</a:t>
-            </a:r>
-          </a:p>
-        </p:txBody>
-      </p:sp>
-      <p:sp>
-        <p:nvSpPr>
-          <p:cNvPr id="5" name="TextBox 4"/>
+            <a:pPr algn="ctr">
+              <a:spcAft>
+                <a:spcPts val="800"/>
+              </a:spcAft>
+            </a:pPr>
+            <a:r>
+              <a:rPr sz="1400" b="1">
+                <a:solidFill>
+                  <a:srgbClr val="FFFFFF"/>
+                </a:solidFill>
+                <a:latin typeface="Arial"/>
+              </a:rPr>
+              <a:t>50+</a:t>
+            </a:r>
+          </a:p>
+        </p:txBody>
+      </p:sp>
+      <p:sp>
+        <p:nvSpPr>
+          <p:cNvPr id="9" name="TextBox 8"/>
           <p:cNvSpPr txBox="1"/>
           <p:nvPr/>
         </p:nvSpPr>
         <p:spPr>
           <a:xfrm>
-            <a:off x="640080" y="1828800"/>
-            <a:ext cx="10972800" cy="2011680"/>
+            <a:off x="1371600" y="475488"/>
+            <a:ext cx="5486400" cy="457200"/>
           </a:xfrm>
           <a:prstGeom prst="rect">
             <a:avLst/>
@@ -5082,43 +5254,27 @@
               </a:spcAft>
             </a:pPr>
             <a:r>
-              <a:rPr sz="4000" b="1">
+              <a:rPr sz="2200" b="1">
                 <a:solidFill>
                   <a:srgbClr val="FFFFFF"/>
                 </a:solidFill>
                 <a:latin typeface="Arial"/>
               </a:rPr>
-              <a:t>You're not bad at technology.</a:t>
-            </a:r>
-          </a:p>
-          <a:p>
-            <a:pPr algn="l">
-              <a:spcAft>
-                <a:spcPts val="800"/>
-              </a:spcAft>
-            </a:pPr>
-            <a:r>
-              <a:rPr sz="3200" b="0">
-                <a:solidFill>
-                  <a:srgbClr val="C8DFF0"/>
-                </a:solidFill>
-                <a:latin typeface="Arial"/>
-              </a:rPr>
-              <a:t>You've just never had the right teacher.</a:t>
-            </a:r>
-          </a:p>
-        </p:txBody>
-      </p:sp>
-      <p:sp>
-        <p:nvSpPr>
-          <p:cNvPr id="6" name="TextBox 5"/>
+              <a:t>TechBridge</a:t>
+            </a:r>
+          </a:p>
+        </p:txBody>
+      </p:sp>
+      <p:sp>
+        <p:nvSpPr>
+          <p:cNvPr id="10" name="TextBox 9"/>
           <p:cNvSpPr txBox="1"/>
           <p:nvPr/>
         </p:nvSpPr>
         <p:spPr>
           <a:xfrm>
-            <a:off x="640080" y="4937760"/>
-            <a:ext cx="10972800" cy="1097280"/>
+            <a:off x="640080" y="1371600"/>
+            <a:ext cx="10972800" cy="365760"/>
           </a:xfrm>
           <a:prstGeom prst="rect">
             <a:avLst/>
@@ -5137,6 +5293,100 @@
               </a:spcAft>
             </a:pPr>
             <a:r>
+              <a:rPr sz="1600" b="1">
+                <a:solidFill>
+                  <a:srgbClr val="65BD53"/>
+                </a:solidFill>
+                <a:latin typeface="Arial"/>
+              </a:rPr>
+              <a:t>FREE ONLINE LEARNING</a:t>
+            </a:r>
+          </a:p>
+        </p:txBody>
+      </p:sp>
+      <p:sp>
+        <p:nvSpPr>
+          <p:cNvPr id="11" name="TextBox 10"/>
+          <p:cNvSpPr txBox="1"/>
+          <p:nvPr/>
+        </p:nvSpPr>
+        <p:spPr>
+          <a:xfrm>
+            <a:off x="640080" y="1828800"/>
+            <a:ext cx="10972800" cy="2011680"/>
+          </a:xfrm>
+          <a:prstGeom prst="rect">
+            <a:avLst/>
+          </a:prstGeom>
+          <a:noFill/>
+        </p:spPr>
+        <p:txBody>
+          <a:bodyPr wrap="square">
+            <a:spAutoFit/>
+          </a:bodyPr>
+          <a:lstStyle/>
+          <a:p>
+            <a:pPr algn="l">
+              <a:spcAft>
+                <a:spcPts val="800"/>
+              </a:spcAft>
+            </a:pPr>
+            <a:r>
+              <a:rPr sz="4000" b="1">
+                <a:solidFill>
+                  <a:srgbClr val="FFFFFF"/>
+                </a:solidFill>
+                <a:latin typeface="Arial"/>
+              </a:rPr>
+              <a:t>You're not bad at technology.</a:t>
+            </a:r>
+          </a:p>
+          <a:p>
+            <a:pPr algn="l">
+              <a:spcAft>
+                <a:spcPts val="800"/>
+              </a:spcAft>
+            </a:pPr>
+            <a:r>
+              <a:rPr sz="3200" b="0">
+                <a:solidFill>
+                  <a:srgbClr val="C8DFF0"/>
+                </a:solidFill>
+                <a:latin typeface="Arial"/>
+              </a:rPr>
+              <a:t>You've just never had the right teacher.</a:t>
+            </a:r>
+          </a:p>
+        </p:txBody>
+      </p:sp>
+      <p:sp>
+        <p:nvSpPr>
+          <p:cNvPr id="12" name="TextBox 11"/>
+          <p:cNvSpPr txBox="1"/>
+          <p:nvPr/>
+        </p:nvSpPr>
+        <p:spPr>
+          <a:xfrm>
+            <a:off x="640080" y="4937760"/>
+            <a:ext cx="10972800" cy="1097280"/>
+          </a:xfrm>
+          <a:prstGeom prst="rect">
+            <a:avLst/>
+          </a:prstGeom>
+          <a:noFill/>
+        </p:spPr>
+        <p:txBody>
+          <a:bodyPr wrap="square">
+            <a:spAutoFit/>
+          </a:bodyPr>
+          <a:lstStyle/>
+          <a:p>
+            <a:pPr algn="l">
+              <a:spcAft>
+                <a:spcPts val="800"/>
+              </a:spcAft>
+            </a:pPr>
+            <a:r>
               <a:rPr sz="2200" b="1">
                 <a:solidFill>
                   <a:srgbClr val="00A3DC"/>
@@ -5155,11 +5405,11 @@
             <a:r>
               <a:rPr sz="1600" b="0">
                 <a:solidFill>
-                  <a:srgbClr val="9AB0C0"/>
-                </a:solidFill>
-                <a:latin typeface="Arial"/>
-              </a:rPr>
-              <a:t>50+TechBridge  ·  Learn More Technologies  ·  Always free</a:t>
+                  <a:srgbClr val="65BD53"/>
+                </a:solidFill>
+                <a:latin typeface="Arial"/>
+              </a:rPr>
+              <a:t>50+ TechBridge  ·  Learn More Technologies  ·  Always free</a:t>
             </a:r>
           </a:p>
         </p:txBody>
@@ -5234,7 +5484,50 @@
         <p:spPr>
           <a:xfrm>
             <a:off x="0" y="0"/>
-            <a:ext cx="12191695" cy="109728"/>
+            <a:ext cx="4206240" cy="6858000"/>
+          </a:xfrm>
+          <a:prstGeom prst="rect">
+            <a:avLst/>
+          </a:prstGeom>
+          <a:solidFill>
+            <a:srgbClr val="2B315F"/>
+          </a:solidFill>
+          <a:ln>
+            <a:noFill/>
+          </a:ln>
+        </p:spPr>
+        <p:style>
+          <a:lnRef idx="1">
+            <a:schemeClr val="accent1"/>
+          </a:lnRef>
+          <a:fillRef idx="3">
+            <a:schemeClr val="accent1"/>
+          </a:fillRef>
+          <a:effectRef idx="2">
+            <a:schemeClr val="accent1"/>
+          </a:effectRef>
+          <a:fontRef idx="minor">
+            <a:schemeClr val="lt1"/>
+          </a:fontRef>
+        </p:style>
+        <p:txBody>
+          <a:bodyPr rtlCol="0" anchor="ctr"/>
+          <a:lstStyle/>
+          <a:p>
+            <a:pPr algn="ctr"/>
+          </a:p>
+        </p:txBody>
+      </p:sp>
+      <p:sp>
+        <p:nvSpPr>
+          <p:cNvPr id="4" name="Rectangle 3"/>
+          <p:cNvSpPr/>
+          <p:nvPr/>
+        </p:nvSpPr>
+        <p:spPr>
+          <a:xfrm>
+            <a:off x="0" y="6784848"/>
+            <a:ext cx="12191695" cy="73152"/>
           </a:xfrm>
           <a:prstGeom prst="rect">
             <a:avLst/>
@@ -5270,7 +5563,50 @@
       </p:sp>
       <p:sp>
         <p:nvSpPr>
-          <p:cNvPr id="4" name="TextBox 3"/>
+          <p:cNvPr id="5" name="Rectangle 4"/>
+          <p:cNvSpPr/>
+          <p:nvPr/>
+        </p:nvSpPr>
+        <p:spPr>
+          <a:xfrm>
+            <a:off x="0" y="0"/>
+            <a:ext cx="12191695" cy="109728"/>
+          </a:xfrm>
+          <a:prstGeom prst="rect">
+            <a:avLst/>
+          </a:prstGeom>
+          <a:solidFill>
+            <a:srgbClr val="00A3DC"/>
+          </a:solidFill>
+          <a:ln>
+            <a:noFill/>
+          </a:ln>
+        </p:spPr>
+        <p:style>
+          <a:lnRef idx="1">
+            <a:schemeClr val="accent1"/>
+          </a:lnRef>
+          <a:fillRef idx="3">
+            <a:schemeClr val="accent1"/>
+          </a:fillRef>
+          <a:effectRef idx="2">
+            <a:schemeClr val="accent1"/>
+          </a:effectRef>
+          <a:fontRef idx="minor">
+            <a:schemeClr val="lt1"/>
+          </a:fontRef>
+        </p:style>
+        <p:txBody>
+          <a:bodyPr rtlCol="0" anchor="ctr"/>
+          <a:lstStyle/>
+          <a:p>
+            <a:pPr algn="ctr"/>
+          </a:p>
+        </p:txBody>
+      </p:sp>
+      <p:sp>
+        <p:nvSpPr>
+          <p:cNvPr id="6" name="TextBox 5"/>
           <p:cNvSpPr txBox="1"/>
           <p:nvPr/>
         </p:nvSpPr>
@@ -5325,7 +5661,7 @@
       </p:sp>
       <p:sp>
         <p:nvSpPr>
-          <p:cNvPr id="5" name="TextBox 4"/>
+          <p:cNvPr id="7" name="TextBox 6"/>
           <p:cNvSpPr txBox="1"/>
           <p:nvPr/>
         </p:nvSpPr>
@@ -5364,7 +5700,7 @@
       </p:sp>
       <p:sp>
         <p:nvSpPr>
-          <p:cNvPr id="6" name="TextBox 5"/>
+          <p:cNvPr id="8" name="TextBox 7"/>
           <p:cNvSpPr txBox="1"/>
           <p:nvPr/>
         </p:nvSpPr>
@@ -5403,7 +5739,7 @@
       </p:sp>
       <p:sp>
         <p:nvSpPr>
-          <p:cNvPr id="7" name="TextBox 6"/>
+          <p:cNvPr id="9" name="TextBox 8"/>
           <p:cNvSpPr txBox="1"/>
           <p:nvPr/>
         </p:nvSpPr>
@@ -5431,18 +5767,18 @@
             <a:r>
               <a:rPr sz="1200" b="0">
                 <a:solidFill>
-                  <a:srgbClr val="9AB0C0"/>
-                </a:solidFill>
-                <a:latin typeface="Arial"/>
-              </a:rPr>
-              <a:t>50+TechBridge  ·  Free Lessons  ·  Always free</a:t>
-            </a:r>
-          </a:p>
-        </p:txBody>
-      </p:sp>
-      <p:sp>
-        <p:nvSpPr>
-          <p:cNvPr id="8" name="TextBox 7"/>
+                  <a:srgbClr val="C8DFF0"/>
+                </a:solidFill>
+                <a:latin typeface="Arial"/>
+              </a:rPr>
+              <a:t>50+ TechBridge  ·  Free Lessons  ·  Always free</a:t>
+            </a:r>
+          </a:p>
+        </p:txBody>
+      </p:sp>
+      <p:sp>
+        <p:nvSpPr>
+          <p:cNvPr id="10" name="TextBox 9"/>
           <p:cNvSpPr txBox="1"/>
           <p:nvPr/>
         </p:nvSpPr>
@@ -5470,7 +5806,7 @@
             <a:r>
               <a:rPr sz="1200" b="0">
                 <a:solidFill>
-                  <a:srgbClr val="9AB0C0"/>
+                  <a:srgbClr val="C8DFF0"/>
                 </a:solidFill>
                 <a:latin typeface="Arial"/>
               </a:rPr>
@@ -5512,7 +5848,7 @@
             <a:avLst/>
           </a:prstGeom>
           <a:solidFill>
-            <a:srgbClr val="F7F4EF"/>
+            <a:srgbClr val="FFFFFF"/>
           </a:solidFill>
           <a:ln>
             <a:noFill/>
@@ -5585,7 +5921,50 @@
       </p:sp>
       <p:sp>
         <p:nvSpPr>
-          <p:cNvPr id="4" name="TextBox 3"/>
+          <p:cNvPr id="4" name="Rectangle 3"/>
+          <p:cNvSpPr/>
+          <p:nvPr/>
+        </p:nvSpPr>
+        <p:spPr>
+          <a:xfrm>
+            <a:off x="0" y="6784848"/>
+            <a:ext cx="12191695" cy="73152"/>
+          </a:xfrm>
+          <a:prstGeom prst="rect">
+            <a:avLst/>
+          </a:prstGeom>
+          <a:solidFill>
+            <a:srgbClr val="00A3DC"/>
+          </a:solidFill>
+          <a:ln>
+            <a:noFill/>
+          </a:ln>
+        </p:spPr>
+        <p:style>
+          <a:lnRef idx="1">
+            <a:schemeClr val="accent1"/>
+          </a:lnRef>
+          <a:fillRef idx="3">
+            <a:schemeClr val="accent1"/>
+          </a:fillRef>
+          <a:effectRef idx="2">
+            <a:schemeClr val="accent1"/>
+          </a:effectRef>
+          <a:fontRef idx="minor">
+            <a:schemeClr val="lt1"/>
+          </a:fontRef>
+        </p:style>
+        <p:txBody>
+          <a:bodyPr rtlCol="0" anchor="ctr"/>
+          <a:lstStyle/>
+          <a:p>
+            <a:pPr algn="ctr"/>
+          </a:p>
+        </p:txBody>
+      </p:sp>
+      <p:sp>
+        <p:nvSpPr>
+          <p:cNvPr id="5" name="TextBox 4"/>
           <p:cNvSpPr txBox="1"/>
           <p:nvPr/>
         </p:nvSpPr>
@@ -5624,7 +6003,7 @@
       </p:sp>
       <p:sp>
         <p:nvSpPr>
-          <p:cNvPr id="5" name="Rectangle 4"/>
+          <p:cNvPr id="6" name="Rectangle 5"/>
           <p:cNvSpPr/>
           <p:nvPr/>
         </p:nvSpPr>
@@ -5667,7 +6046,7 @@
       </p:sp>
       <p:sp>
         <p:nvSpPr>
-          <p:cNvPr id="6" name="TextBox 5"/>
+          <p:cNvPr id="7" name="TextBox 6"/>
           <p:cNvSpPr txBox="1"/>
           <p:nvPr/>
         </p:nvSpPr>
@@ -5770,7 +6149,7 @@
       </p:sp>
       <p:sp>
         <p:nvSpPr>
-          <p:cNvPr id="7" name="Rectangle 6"/>
+          <p:cNvPr id="8" name="Rectangle 7"/>
           <p:cNvSpPr/>
           <p:nvPr/>
         </p:nvSpPr>
@@ -5813,7 +6192,7 @@
       </p:sp>
       <p:sp>
         <p:nvSpPr>
-          <p:cNvPr id="8" name="TextBox 7"/>
+          <p:cNvPr id="9" name="TextBox 8"/>
           <p:cNvSpPr txBox="1"/>
           <p:nvPr/>
         </p:nvSpPr>
@@ -5916,7 +6295,7 @@
       </p:sp>
       <p:sp>
         <p:nvSpPr>
-          <p:cNvPr id="9" name="TextBox 8"/>
+          <p:cNvPr id="10" name="TextBox 9"/>
           <p:cNvSpPr txBox="1"/>
           <p:nvPr/>
         </p:nvSpPr>
@@ -5944,18 +6323,18 @@
             <a:r>
               <a:rPr sz="1200" b="0">
                 <a:solidFill>
-                  <a:srgbClr val="5B6B7C"/>
-                </a:solidFill>
-                <a:latin typeface="Arial"/>
-              </a:rPr>
-              <a:t>50+TechBridge  ·  Free Lessons  ·  Always free</a:t>
-            </a:r>
-          </a:p>
-        </p:txBody>
-      </p:sp>
-      <p:sp>
-        <p:nvSpPr>
-          <p:cNvPr id="10" name="TextBox 9"/>
+                  <a:srgbClr val="4A5568"/>
+                </a:solidFill>
+                <a:latin typeface="Arial"/>
+              </a:rPr>
+              <a:t>50+ TechBridge  ·  Free Lessons  ·  Always free</a:t>
+            </a:r>
+          </a:p>
+        </p:txBody>
+      </p:sp>
+      <p:sp>
+        <p:nvSpPr>
+          <p:cNvPr id="11" name="TextBox 10"/>
           <p:cNvSpPr txBox="1"/>
           <p:nvPr/>
         </p:nvSpPr>
@@ -5983,7 +6362,7 @@
             <a:r>
               <a:rPr sz="1200" b="0">
                 <a:solidFill>
-                  <a:srgbClr val="5B6B7C"/>
+                  <a:srgbClr val="4A5568"/>
                 </a:solidFill>
                 <a:latin typeface="Arial"/>
               </a:rPr>
@@ -6062,6 +6441,92 @@
         <p:spPr>
           <a:xfrm>
             <a:off x="0" y="0"/>
+            <a:ext cx="4206240" cy="6858000"/>
+          </a:xfrm>
+          <a:prstGeom prst="rect">
+            <a:avLst/>
+          </a:prstGeom>
+          <a:solidFill>
+            <a:srgbClr val="2B315F"/>
+          </a:solidFill>
+          <a:ln>
+            <a:noFill/>
+          </a:ln>
+        </p:spPr>
+        <p:style>
+          <a:lnRef idx="1">
+            <a:schemeClr val="accent1"/>
+          </a:lnRef>
+          <a:fillRef idx="3">
+            <a:schemeClr val="accent1"/>
+          </a:fillRef>
+          <a:effectRef idx="2">
+            <a:schemeClr val="accent1"/>
+          </a:effectRef>
+          <a:fontRef idx="minor">
+            <a:schemeClr val="lt1"/>
+          </a:fontRef>
+        </p:style>
+        <p:txBody>
+          <a:bodyPr rtlCol="0" anchor="ctr"/>
+          <a:lstStyle/>
+          <a:p>
+            <a:pPr algn="ctr"/>
+          </a:p>
+        </p:txBody>
+      </p:sp>
+      <p:sp>
+        <p:nvSpPr>
+          <p:cNvPr id="4" name="Rectangle 3"/>
+          <p:cNvSpPr/>
+          <p:nvPr/>
+        </p:nvSpPr>
+        <p:spPr>
+          <a:xfrm>
+            <a:off x="0" y="6784848"/>
+            <a:ext cx="12191695" cy="73152"/>
+          </a:xfrm>
+          <a:prstGeom prst="rect">
+            <a:avLst/>
+          </a:prstGeom>
+          <a:solidFill>
+            <a:srgbClr val="00A3DC"/>
+          </a:solidFill>
+          <a:ln>
+            <a:noFill/>
+          </a:ln>
+        </p:spPr>
+        <p:style>
+          <a:lnRef idx="1">
+            <a:schemeClr val="accent1"/>
+          </a:lnRef>
+          <a:fillRef idx="3">
+            <a:schemeClr val="accent1"/>
+          </a:fillRef>
+          <a:effectRef idx="2">
+            <a:schemeClr val="accent1"/>
+          </a:effectRef>
+          <a:fontRef idx="minor">
+            <a:schemeClr val="lt1"/>
+          </a:fontRef>
+        </p:style>
+        <p:txBody>
+          <a:bodyPr rtlCol="0" anchor="ctr"/>
+          <a:lstStyle/>
+          <a:p>
+            <a:pPr algn="ctr"/>
+          </a:p>
+        </p:txBody>
+      </p:sp>
+      <p:sp>
+        <p:nvSpPr>
+          <p:cNvPr id="5" name="Rectangle 4"/>
+          <p:cNvSpPr/>
+          <p:nvPr/>
+        </p:nvSpPr>
+        <p:spPr>
+          <a:xfrm>
+            <a:off x="0" y="0"/>
             <a:ext cx="201168" cy="6858000"/>
           </a:xfrm>
           <a:prstGeom prst="rect">
@@ -6098,7 +6563,7 @@
       </p:sp>
       <p:sp>
         <p:nvSpPr>
-          <p:cNvPr id="4" name="TextBox 3"/>
+          <p:cNvPr id="6" name="TextBox 5"/>
           <p:cNvSpPr txBox="1"/>
           <p:nvPr/>
         </p:nvSpPr>
@@ -6169,7 +6634,7 @@
       </p:sp>
       <p:sp>
         <p:nvSpPr>
-          <p:cNvPr id="5" name="TextBox 4"/>
+          <p:cNvPr id="7" name="TextBox 6"/>
           <p:cNvSpPr txBox="1"/>
           <p:nvPr/>
         </p:nvSpPr>
@@ -6197,18 +6662,18 @@
             <a:r>
               <a:rPr sz="1200" b="0">
                 <a:solidFill>
-                  <a:srgbClr val="9AB0C0"/>
-                </a:solidFill>
-                <a:latin typeface="Arial"/>
-              </a:rPr>
-              <a:t>50+TechBridge  ·  Free Lessons  ·  Always free</a:t>
-            </a:r>
-          </a:p>
-        </p:txBody>
-      </p:sp>
-      <p:sp>
-        <p:nvSpPr>
-          <p:cNvPr id="6" name="TextBox 5"/>
+                  <a:srgbClr val="C8DFF0"/>
+                </a:solidFill>
+                <a:latin typeface="Arial"/>
+              </a:rPr>
+              <a:t>50+ TechBridge  ·  Free Lessons  ·  Always free</a:t>
+            </a:r>
+          </a:p>
+        </p:txBody>
+      </p:sp>
+      <p:sp>
+        <p:nvSpPr>
+          <p:cNvPr id="8" name="TextBox 7"/>
           <p:cNvSpPr txBox="1"/>
           <p:nvPr/>
         </p:nvSpPr>
@@ -6236,7 +6701,7 @@
             <a:r>
               <a:rPr sz="1200" b="0">
                 <a:solidFill>
-                  <a:srgbClr val="9AB0C0"/>
+                  <a:srgbClr val="C8DFF0"/>
                 </a:solidFill>
                 <a:latin typeface="Arial"/>
               </a:rPr>
@@ -6278,7 +6743,7 @@
             <a:avLst/>
           </a:prstGeom>
           <a:solidFill>
-            <a:srgbClr val="F7F4EF"/>
+            <a:srgbClr val="FFFFFF"/>
           </a:solidFill>
           <a:ln>
             <a:noFill/>
@@ -6351,7 +6816,50 @@
       </p:sp>
       <p:sp>
         <p:nvSpPr>
-          <p:cNvPr id="4" name="TextBox 3"/>
+          <p:cNvPr id="4" name="Rectangle 3"/>
+          <p:cNvSpPr/>
+          <p:nvPr/>
+        </p:nvSpPr>
+        <p:spPr>
+          <a:xfrm>
+            <a:off x="0" y="6784848"/>
+            <a:ext cx="12191695" cy="73152"/>
+          </a:xfrm>
+          <a:prstGeom prst="rect">
+            <a:avLst/>
+          </a:prstGeom>
+          <a:solidFill>
+            <a:srgbClr val="00A3DC"/>
+          </a:solidFill>
+          <a:ln>
+            <a:noFill/>
+          </a:ln>
+        </p:spPr>
+        <p:style>
+          <a:lnRef idx="1">
+            <a:schemeClr val="accent1"/>
+          </a:lnRef>
+          <a:fillRef idx="3">
+            <a:schemeClr val="accent1"/>
+          </a:fillRef>
+          <a:effectRef idx="2">
+            <a:schemeClr val="accent1"/>
+          </a:effectRef>
+          <a:fontRef idx="minor">
+            <a:schemeClr val="lt1"/>
+          </a:fontRef>
+        </p:style>
+        <p:txBody>
+          <a:bodyPr rtlCol="0" anchor="ctr"/>
+          <a:lstStyle/>
+          <a:p>
+            <a:pPr algn="ctr"/>
+          </a:p>
+        </p:txBody>
+      </p:sp>
+      <p:sp>
+        <p:nvSpPr>
+          <p:cNvPr id="5" name="TextBox 4"/>
           <p:cNvSpPr txBox="1"/>
           <p:nvPr/>
         </p:nvSpPr>
@@ -6395,7 +6903,7 @@
             <a:r>
               <a:rPr sz="1600" b="0">
                 <a:solidFill>
-                  <a:srgbClr val="3D4A5C"/>
+                  <a:srgbClr val="4A5568"/>
                 </a:solidFill>
                 <a:latin typeface="Arial"/>
               </a:rPr>
@@ -6406,7 +6914,7 @@
       </p:sp>
       <p:sp>
         <p:nvSpPr>
-          <p:cNvPr id="5" name="Rectangle 4"/>
+          <p:cNvPr id="6" name="Rectangle 5"/>
           <p:cNvSpPr/>
           <p:nvPr/>
         </p:nvSpPr>
@@ -6449,7 +6957,7 @@
       </p:sp>
       <p:sp>
         <p:nvSpPr>
-          <p:cNvPr id="6" name="TextBox 5"/>
+          <p:cNvPr id="7" name="TextBox 6"/>
           <p:cNvSpPr txBox="1"/>
           <p:nvPr/>
         </p:nvSpPr>
@@ -6536,7 +7044,7 @@
       </p:sp>
       <p:sp>
         <p:nvSpPr>
-          <p:cNvPr id="7" name="Rectangle 6"/>
+          <p:cNvPr id="8" name="Rectangle 7"/>
           <p:cNvSpPr/>
           <p:nvPr/>
         </p:nvSpPr>
@@ -6579,7 +7087,7 @@
       </p:sp>
       <p:sp>
         <p:nvSpPr>
-          <p:cNvPr id="8" name="TextBox 7"/>
+          <p:cNvPr id="9" name="TextBox 8"/>
           <p:cNvSpPr txBox="1"/>
           <p:nvPr/>
         </p:nvSpPr>
@@ -6666,7 +7174,7 @@
       </p:sp>
       <p:sp>
         <p:nvSpPr>
-          <p:cNvPr id="9" name="TextBox 8"/>
+          <p:cNvPr id="10" name="TextBox 9"/>
           <p:cNvSpPr txBox="1"/>
           <p:nvPr/>
         </p:nvSpPr>
@@ -6694,18 +7202,18 @@
             <a:r>
               <a:rPr sz="1200" b="0">
                 <a:solidFill>
-                  <a:srgbClr val="5B6B7C"/>
-                </a:solidFill>
-                <a:latin typeface="Arial"/>
-              </a:rPr>
-              <a:t>50+TechBridge  ·  Free Lessons  ·  Always free</a:t>
-            </a:r>
-          </a:p>
-        </p:txBody>
-      </p:sp>
-      <p:sp>
-        <p:nvSpPr>
-          <p:cNvPr id="10" name="TextBox 9"/>
+                  <a:srgbClr val="4A5568"/>
+                </a:solidFill>
+                <a:latin typeface="Arial"/>
+              </a:rPr>
+              <a:t>50+ TechBridge  ·  Free Lessons  ·  Always free</a:t>
+            </a:r>
+          </a:p>
+        </p:txBody>
+      </p:sp>
+      <p:sp>
+        <p:nvSpPr>
+          <p:cNvPr id="11" name="TextBox 10"/>
           <p:cNvSpPr txBox="1"/>
           <p:nvPr/>
         </p:nvSpPr>
@@ -6733,7 +7241,7 @@
             <a:r>
               <a:rPr sz="1200" b="0">
                 <a:solidFill>
-                  <a:srgbClr val="5B6B7C"/>
+                  <a:srgbClr val="4A5568"/>
                 </a:solidFill>
                 <a:latin typeface="Arial"/>
               </a:rPr>
@@ -6775,7 +7283,7 @@
             <a:avLst/>
           </a:prstGeom>
           <a:solidFill>
-            <a:srgbClr val="F7F4EF"/>
+            <a:srgbClr val="FFFFFF"/>
           </a:solidFill>
           <a:ln>
             <a:noFill/>
@@ -6848,59 +7356,20 @@
       </p:sp>
       <p:sp>
         <p:nvSpPr>
-          <p:cNvPr id="4" name="TextBox 3"/>
-          <p:cNvSpPr txBox="1"/>
-          <p:nvPr/>
-        </p:nvSpPr>
-        <p:spPr>
-          <a:xfrm>
-            <a:off x="548640" y="320040"/>
-            <a:ext cx="10972800" cy="731520"/>
-          </a:xfrm>
-          <a:prstGeom prst="rect">
-            <a:avLst/>
-          </a:prstGeom>
-          <a:noFill/>
-        </p:spPr>
-        <p:txBody>
-          <a:bodyPr wrap="square">
-            <a:spAutoFit/>
-          </a:bodyPr>
-          <a:lstStyle/>
-          <a:p>
-            <a:pPr algn="l">
-              <a:spcAft>
-                <a:spcPts val="800"/>
-              </a:spcAft>
-            </a:pPr>
-            <a:r>
-              <a:rPr sz="3400" b="1">
-                <a:solidFill>
-                  <a:srgbClr val="083655"/>
-                </a:solidFill>
-                <a:latin typeface="Arial"/>
-              </a:rPr>
-              <a:t>Skill 1  ·  Spot a fake</a:t>
-            </a:r>
-          </a:p>
-        </p:txBody>
-      </p:sp>
-      <p:sp>
-        <p:nvSpPr>
-          <p:cNvPr id="5" name="Rectangle 4"/>
+          <p:cNvPr id="4" name="Rectangle 3"/>
           <p:cNvSpPr/>
           <p:nvPr/>
         </p:nvSpPr>
         <p:spPr>
           <a:xfrm>
-            <a:off x="548640" y="1234440"/>
-            <a:ext cx="5532120" cy="2103120"/>
+            <a:off x="0" y="6784848"/>
+            <a:ext cx="12191695" cy="73152"/>
           </a:xfrm>
           <a:prstGeom prst="rect">
             <a:avLst/>
           </a:prstGeom>
           <a:solidFill>
-            <a:srgbClr val="FFFFFF"/>
+            <a:srgbClr val="00A3DC"/>
           </a:solidFill>
           <a:ln>
             <a:noFill/>
@@ -6930,7 +7399,89 @@
       </p:sp>
       <p:sp>
         <p:nvSpPr>
+          <p:cNvPr id="5" name="TextBox 4"/>
+          <p:cNvSpPr txBox="1"/>
+          <p:nvPr/>
+        </p:nvSpPr>
+        <p:spPr>
+          <a:xfrm>
+            <a:off x="548640" y="320040"/>
+            <a:ext cx="10972800" cy="731520"/>
+          </a:xfrm>
+          <a:prstGeom prst="rect">
+            <a:avLst/>
+          </a:prstGeom>
+          <a:noFill/>
+        </p:spPr>
+        <p:txBody>
+          <a:bodyPr wrap="square">
+            <a:spAutoFit/>
+          </a:bodyPr>
+          <a:lstStyle/>
+          <a:p>
+            <a:pPr algn="l">
+              <a:spcAft>
+                <a:spcPts val="800"/>
+              </a:spcAft>
+            </a:pPr>
+            <a:r>
+              <a:rPr sz="3400" b="1">
+                <a:solidFill>
+                  <a:srgbClr val="083655"/>
+                </a:solidFill>
+                <a:latin typeface="Arial"/>
+              </a:rPr>
+              <a:t>Skill 1  ·  Spot a fake</a:t>
+            </a:r>
+          </a:p>
+        </p:txBody>
+      </p:sp>
+      <p:sp>
+        <p:nvSpPr>
           <p:cNvPr id="6" name="Rectangle 5"/>
+          <p:cNvSpPr/>
+          <p:nvPr/>
+        </p:nvSpPr>
+        <p:spPr>
+          <a:xfrm>
+            <a:off x="548640" y="1234440"/>
+            <a:ext cx="5532120" cy="2103120"/>
+          </a:xfrm>
+          <a:prstGeom prst="rect">
+            <a:avLst/>
+          </a:prstGeom>
+          <a:solidFill>
+            <a:srgbClr val="F0F8FF"/>
+          </a:solidFill>
+          <a:ln>
+            <a:noFill/>
+          </a:ln>
+        </p:spPr>
+        <p:style>
+          <a:lnRef idx="1">
+            <a:schemeClr val="accent1"/>
+          </a:lnRef>
+          <a:fillRef idx="3">
+            <a:schemeClr val="accent1"/>
+          </a:fillRef>
+          <a:effectRef idx="2">
+            <a:schemeClr val="accent1"/>
+          </a:effectRef>
+          <a:fontRef idx="minor">
+            <a:schemeClr val="lt1"/>
+          </a:fontRef>
+        </p:style>
+        <p:txBody>
+          <a:bodyPr rtlCol="0" anchor="ctr"/>
+          <a:lstStyle/>
+          <a:p>
+            <a:pPr algn="ctr"/>
+          </a:p>
+        </p:txBody>
+      </p:sp>
+      <p:sp>
+        <p:nvSpPr>
+          <p:cNvPr id="7" name="Rectangle 6"/>
           <p:cNvSpPr/>
           <p:nvPr/>
         </p:nvSpPr>
@@ -6973,7 +7524,7 @@
       </p:sp>
       <p:sp>
         <p:nvSpPr>
-          <p:cNvPr id="7" name="TextBox 6"/>
+          <p:cNvPr id="8" name="TextBox 7"/>
           <p:cNvSpPr txBox="1"/>
           <p:nvPr/>
         </p:nvSpPr>
@@ -7017,7 +7568,7 @@
             <a:r>
               <a:rPr sz="1800" b="0">
                 <a:solidFill>
-                  <a:srgbClr val="3D4A5C"/>
+                  <a:srgbClr val="4A5568"/>
                 </a:solidFill>
                 <a:latin typeface="Arial"/>
               </a:rPr>
@@ -7028,7 +7579,7 @@
       </p:sp>
       <p:sp>
         <p:nvSpPr>
-          <p:cNvPr id="8" name="Rectangle 7"/>
+          <p:cNvPr id="9" name="Rectangle 8"/>
           <p:cNvSpPr/>
           <p:nvPr/>
         </p:nvSpPr>
@@ -7041,7 +7592,7 @@
             <a:avLst/>
           </a:prstGeom>
           <a:solidFill>
-            <a:srgbClr val="FFFFFF"/>
+            <a:srgbClr val="F0F8FF"/>
           </a:solidFill>
           <a:ln>
             <a:noFill/>
@@ -7071,7 +7622,7 @@
       </p:sp>
       <p:sp>
         <p:nvSpPr>
-          <p:cNvPr id="9" name="Rectangle 8"/>
+          <p:cNvPr id="10" name="Rectangle 9"/>
           <p:cNvSpPr/>
           <p:nvPr/>
         </p:nvSpPr>
@@ -7114,7 +7665,7 @@
       </p:sp>
       <p:sp>
         <p:nvSpPr>
-          <p:cNvPr id="10" name="TextBox 9"/>
+          <p:cNvPr id="11" name="TextBox 10"/>
           <p:cNvSpPr txBox="1"/>
           <p:nvPr/>
         </p:nvSpPr>
@@ -7158,7 +7709,7 @@
             <a:r>
               <a:rPr sz="1800" b="0">
                 <a:solidFill>
-                  <a:srgbClr val="3D4A5C"/>
+                  <a:srgbClr val="4A5568"/>
                 </a:solidFill>
                 <a:latin typeface="Arial"/>
               </a:rPr>
@@ -7169,7 +7720,7 @@
       </p:sp>
       <p:sp>
         <p:nvSpPr>
-          <p:cNvPr id="11" name="Rectangle 10"/>
+          <p:cNvPr id="12" name="Rectangle 11"/>
           <p:cNvSpPr/>
           <p:nvPr/>
         </p:nvSpPr>
@@ -7182,7 +7733,7 @@
             <a:avLst/>
           </a:prstGeom>
           <a:solidFill>
-            <a:srgbClr val="FFFFFF"/>
+            <a:srgbClr val="F0F8FF"/>
           </a:solidFill>
           <a:ln>
             <a:noFill/>
@@ -7212,7 +7763,7 @@
       </p:sp>
       <p:sp>
         <p:nvSpPr>
-          <p:cNvPr id="12" name="Rectangle 11"/>
+          <p:cNvPr id="13" name="Rectangle 12"/>
           <p:cNvSpPr/>
           <p:nvPr/>
         </p:nvSpPr>
@@ -7255,7 +7806,7 @@
       </p:sp>
       <p:sp>
         <p:nvSpPr>
-          <p:cNvPr id="13" name="TextBox 12"/>
+          <p:cNvPr id="14" name="TextBox 13"/>
           <p:cNvSpPr txBox="1"/>
           <p:nvPr/>
         </p:nvSpPr>
@@ -7299,7 +7850,7 @@
             <a:r>
               <a:rPr sz="1800" b="0">
                 <a:solidFill>
-                  <a:srgbClr val="3D4A5C"/>
+                  <a:srgbClr val="4A5568"/>
                 </a:solidFill>
                 <a:latin typeface="Arial"/>
               </a:rPr>
@@ -7310,7 +7861,7 @@
       </p:sp>
       <p:sp>
         <p:nvSpPr>
-          <p:cNvPr id="14" name="Rectangle 13"/>
+          <p:cNvPr id="15" name="Rectangle 14"/>
           <p:cNvSpPr/>
           <p:nvPr/>
         </p:nvSpPr>
@@ -7323,7 +7874,7 @@
             <a:avLst/>
           </a:prstGeom>
           <a:solidFill>
-            <a:srgbClr val="FFFFFF"/>
+            <a:srgbClr val="F0F8FF"/>
           </a:solidFill>
           <a:ln>
             <a:noFill/>
@@ -7353,7 +7904,7 @@
       </p:sp>
       <p:sp>
         <p:nvSpPr>
-          <p:cNvPr id="15" name="Rectangle 14"/>
+          <p:cNvPr id="16" name="Rectangle 15"/>
           <p:cNvSpPr/>
           <p:nvPr/>
         </p:nvSpPr>
@@ -7396,7 +7947,7 @@
       </p:sp>
       <p:sp>
         <p:nvSpPr>
-          <p:cNvPr id="16" name="TextBox 15"/>
+          <p:cNvPr id="17" name="TextBox 16"/>
           <p:cNvSpPr txBox="1"/>
           <p:nvPr/>
         </p:nvSpPr>
@@ -7440,7 +7991,7 @@
             <a:r>
               <a:rPr sz="1800" b="0">
                 <a:solidFill>
-                  <a:srgbClr val="3D4A5C"/>
+                  <a:srgbClr val="4A5568"/>
                 </a:solidFill>
                 <a:latin typeface="Arial"/>
               </a:rPr>
@@ -7451,7 +8002,7 @@
       </p:sp>
       <p:sp>
         <p:nvSpPr>
-          <p:cNvPr id="17" name="TextBox 16"/>
+          <p:cNvPr id="18" name="TextBox 17"/>
           <p:cNvSpPr txBox="1"/>
           <p:nvPr/>
         </p:nvSpPr>
@@ -7479,18 +8030,18 @@
             <a:r>
               <a:rPr sz="1200" b="0">
                 <a:solidFill>
-                  <a:srgbClr val="5B6B7C"/>
-                </a:solidFill>
-                <a:latin typeface="Arial"/>
-              </a:rPr>
-              <a:t>50+TechBridge  ·  Free Lessons  ·  Always free</a:t>
-            </a:r>
-          </a:p>
-        </p:txBody>
-      </p:sp>
-      <p:sp>
-        <p:nvSpPr>
-          <p:cNvPr id="18" name="TextBox 17"/>
+                  <a:srgbClr val="4A5568"/>
+                </a:solidFill>
+                <a:latin typeface="Arial"/>
+              </a:rPr>
+              <a:t>50+ TechBridge  ·  Free Lessons  ·  Always free</a:t>
+            </a:r>
+          </a:p>
+        </p:txBody>
+      </p:sp>
+      <p:sp>
+        <p:nvSpPr>
+          <p:cNvPr id="19" name="TextBox 18"/>
           <p:cNvSpPr txBox="1"/>
           <p:nvPr/>
         </p:nvSpPr>
@@ -7518,7 +8069,7 @@
             <a:r>
               <a:rPr sz="1200" b="0">
                 <a:solidFill>
-                  <a:srgbClr val="5B6B7C"/>
+                  <a:srgbClr val="4A5568"/>
                 </a:solidFill>
                 <a:latin typeface="Arial"/>
               </a:rPr>
@@ -7597,6 +8148,92 @@
         <p:spPr>
           <a:xfrm>
             <a:off x="0" y="0"/>
+            <a:ext cx="4206240" cy="6858000"/>
+          </a:xfrm>
+          <a:prstGeom prst="rect">
+            <a:avLst/>
+          </a:prstGeom>
+          <a:solidFill>
+            <a:srgbClr val="2B315F"/>
+          </a:solidFill>
+          <a:ln>
+            <a:noFill/>
+          </a:ln>
+        </p:spPr>
+        <p:style>
+          <a:lnRef idx="1">
+            <a:schemeClr val="accent1"/>
+          </a:lnRef>
+          <a:fillRef idx="3">
+            <a:schemeClr val="accent1"/>
+          </a:fillRef>
+          <a:effectRef idx="2">
+            <a:schemeClr val="accent1"/>
+          </a:effectRef>
+          <a:fontRef idx="minor">
+            <a:schemeClr val="lt1"/>
+          </a:fontRef>
+        </p:style>
+        <p:txBody>
+          <a:bodyPr rtlCol="0" anchor="ctr"/>
+          <a:lstStyle/>
+          <a:p>
+            <a:pPr algn="ctr"/>
+          </a:p>
+        </p:txBody>
+      </p:sp>
+      <p:sp>
+        <p:nvSpPr>
+          <p:cNvPr id="4" name="Rectangle 3"/>
+          <p:cNvSpPr/>
+          <p:nvPr/>
+        </p:nvSpPr>
+        <p:spPr>
+          <a:xfrm>
+            <a:off x="0" y="6784848"/>
+            <a:ext cx="12191695" cy="73152"/>
+          </a:xfrm>
+          <a:prstGeom prst="rect">
+            <a:avLst/>
+          </a:prstGeom>
+          <a:solidFill>
+            <a:srgbClr val="00A3DC"/>
+          </a:solidFill>
+          <a:ln>
+            <a:noFill/>
+          </a:ln>
+        </p:spPr>
+        <p:style>
+          <a:lnRef idx="1">
+            <a:schemeClr val="accent1"/>
+          </a:lnRef>
+          <a:fillRef idx="3">
+            <a:schemeClr val="accent1"/>
+          </a:fillRef>
+          <a:effectRef idx="2">
+            <a:schemeClr val="accent1"/>
+          </a:effectRef>
+          <a:fontRef idx="minor">
+            <a:schemeClr val="lt1"/>
+          </a:fontRef>
+        </p:style>
+        <p:txBody>
+          <a:bodyPr rtlCol="0" anchor="ctr"/>
+          <a:lstStyle/>
+          <a:p>
+            <a:pPr algn="ctr"/>
+          </a:p>
+        </p:txBody>
+      </p:sp>
+      <p:sp>
+        <p:nvSpPr>
+          <p:cNvPr id="5" name="Rectangle 4"/>
+          <p:cNvSpPr/>
+          <p:nvPr/>
+        </p:nvSpPr>
+        <p:spPr>
+          <a:xfrm>
+            <a:off x="0" y="0"/>
             <a:ext cx="12191695" cy="109728"/>
           </a:xfrm>
           <a:prstGeom prst="rect">
@@ -7633,7 +8270,7 @@
       </p:sp>
       <p:sp>
         <p:nvSpPr>
-          <p:cNvPr id="4" name="TextBox 3"/>
+          <p:cNvPr id="6" name="TextBox 5"/>
           <p:cNvSpPr txBox="1"/>
           <p:nvPr/>
         </p:nvSpPr>
@@ -7672,7 +8309,7 @@
       </p:sp>
       <p:sp>
         <p:nvSpPr>
-          <p:cNvPr id="5" name="Rectangle 4"/>
+          <p:cNvPr id="7" name="Rectangle 6"/>
           <p:cNvSpPr/>
           <p:nvPr/>
         </p:nvSpPr>
@@ -7715,7 +8352,7 @@
       </p:sp>
       <p:sp>
         <p:nvSpPr>
-          <p:cNvPr id="6" name="TextBox 5"/>
+          <p:cNvPr id="8" name="TextBox 7"/>
           <p:cNvSpPr txBox="1"/>
           <p:nvPr/>
         </p:nvSpPr>
@@ -7754,7 +8391,7 @@
       </p:sp>
       <p:sp>
         <p:nvSpPr>
-          <p:cNvPr id="7" name="TextBox 6"/>
+          <p:cNvPr id="9" name="TextBox 8"/>
           <p:cNvSpPr txBox="1"/>
           <p:nvPr/>
         </p:nvSpPr>
@@ -7793,7 +8430,7 @@
       </p:sp>
       <p:sp>
         <p:nvSpPr>
-          <p:cNvPr id="8" name="Rectangle 7"/>
+          <p:cNvPr id="10" name="Rectangle 9"/>
           <p:cNvSpPr/>
           <p:nvPr/>
         </p:nvSpPr>
@@ -7836,7 +8473,7 @@
       </p:sp>
       <p:sp>
         <p:nvSpPr>
-          <p:cNvPr id="9" name="TextBox 8"/>
+          <p:cNvPr id="11" name="TextBox 10"/>
           <p:cNvSpPr txBox="1"/>
           <p:nvPr/>
         </p:nvSpPr>
@@ -7875,7 +8512,7 @@
       </p:sp>
       <p:sp>
         <p:nvSpPr>
-          <p:cNvPr id="10" name="TextBox 9"/>
+          <p:cNvPr id="12" name="TextBox 11"/>
           <p:cNvSpPr txBox="1"/>
           <p:nvPr/>
         </p:nvSpPr>
@@ -7914,7 +8551,7 @@
       </p:sp>
       <p:sp>
         <p:nvSpPr>
-          <p:cNvPr id="11" name="Rectangle 10"/>
+          <p:cNvPr id="13" name="Rectangle 12"/>
           <p:cNvSpPr/>
           <p:nvPr/>
         </p:nvSpPr>
@@ -7957,7 +8594,7 @@
       </p:sp>
       <p:sp>
         <p:nvSpPr>
-          <p:cNvPr id="12" name="TextBox 11"/>
+          <p:cNvPr id="14" name="TextBox 13"/>
           <p:cNvSpPr txBox="1"/>
           <p:nvPr/>
         </p:nvSpPr>
@@ -7996,7 +8633,7 @@
       </p:sp>
       <p:sp>
         <p:nvSpPr>
-          <p:cNvPr id="13" name="TextBox 12"/>
+          <p:cNvPr id="15" name="TextBox 14"/>
           <p:cNvSpPr txBox="1"/>
           <p:nvPr/>
         </p:nvSpPr>
@@ -8035,7 +8672,7 @@
       </p:sp>
       <p:sp>
         <p:nvSpPr>
-          <p:cNvPr id="14" name="Rectangle 13"/>
+          <p:cNvPr id="16" name="Rectangle 15"/>
           <p:cNvSpPr/>
           <p:nvPr/>
         </p:nvSpPr>
@@ -8078,7 +8715,7 @@
       </p:sp>
       <p:sp>
         <p:nvSpPr>
-          <p:cNvPr id="15" name="TextBox 14"/>
+          <p:cNvPr id="17" name="TextBox 16"/>
           <p:cNvSpPr txBox="1"/>
           <p:nvPr/>
         </p:nvSpPr>
@@ -8117,7 +8754,7 @@
       </p:sp>
       <p:sp>
         <p:nvSpPr>
-          <p:cNvPr id="16" name="TextBox 15"/>
+          <p:cNvPr id="18" name="TextBox 17"/>
           <p:cNvSpPr txBox="1"/>
           <p:nvPr/>
         </p:nvSpPr>
@@ -8156,7 +8793,7 @@
       </p:sp>
       <p:sp>
         <p:nvSpPr>
-          <p:cNvPr id="17" name="Rectangle 16"/>
+          <p:cNvPr id="19" name="Rectangle 18"/>
           <p:cNvSpPr/>
           <p:nvPr/>
         </p:nvSpPr>
@@ -8199,7 +8836,7 @@
       </p:sp>
       <p:sp>
         <p:nvSpPr>
-          <p:cNvPr id="18" name="TextBox 17"/>
+          <p:cNvPr id="20" name="TextBox 19"/>
           <p:cNvSpPr txBox="1"/>
           <p:nvPr/>
         </p:nvSpPr>
@@ -8238,7 +8875,7 @@
       </p:sp>
       <p:sp>
         <p:nvSpPr>
-          <p:cNvPr id="19" name="TextBox 18"/>
+          <p:cNvPr id="21" name="TextBox 20"/>
           <p:cNvSpPr txBox="1"/>
           <p:nvPr/>
         </p:nvSpPr>
@@ -8277,7 +8914,7 @@
       </p:sp>
       <p:sp>
         <p:nvSpPr>
-          <p:cNvPr id="20" name="TextBox 19"/>
+          <p:cNvPr id="22" name="TextBox 21"/>
           <p:cNvSpPr txBox="1"/>
           <p:nvPr/>
         </p:nvSpPr>
@@ -8305,18 +8942,18 @@
             <a:r>
               <a:rPr sz="1200" b="0">
                 <a:solidFill>
-                  <a:srgbClr val="9AB0C0"/>
-                </a:solidFill>
-                <a:latin typeface="Arial"/>
-              </a:rPr>
-              <a:t>50+TechBridge  ·  Free Lessons  ·  Always free</a:t>
-            </a:r>
-          </a:p>
-        </p:txBody>
-      </p:sp>
-      <p:sp>
-        <p:nvSpPr>
-          <p:cNvPr id="21" name="TextBox 20"/>
+                  <a:srgbClr val="C8DFF0"/>
+                </a:solidFill>
+                <a:latin typeface="Arial"/>
+              </a:rPr>
+              <a:t>50+ TechBridge  ·  Free Lessons  ·  Always free</a:t>
+            </a:r>
+          </a:p>
+        </p:txBody>
+      </p:sp>
+      <p:sp>
+        <p:nvSpPr>
+          <p:cNvPr id="23" name="TextBox 22"/>
           <p:cNvSpPr txBox="1"/>
           <p:nvPr/>
         </p:nvSpPr>
@@ -8344,7 +8981,7 @@
             <a:r>
               <a:rPr sz="1200" b="0">
                 <a:solidFill>
-                  <a:srgbClr val="9AB0C0"/>
+                  <a:srgbClr val="C8DFF0"/>
                 </a:solidFill>
                 <a:latin typeface="Arial"/>
               </a:rPr>
@@ -8386,7 +9023,7 @@
             <a:avLst/>
           </a:prstGeom>
           <a:solidFill>
-            <a:srgbClr val="F7F4EF"/>
+            <a:srgbClr val="FFFFFF"/>
           </a:solidFill>
           <a:ln>
             <a:noFill/>
@@ -8459,7 +9096,50 @@
       </p:sp>
       <p:sp>
         <p:nvSpPr>
-          <p:cNvPr id="4" name="TextBox 3"/>
+          <p:cNvPr id="4" name="Rectangle 3"/>
+          <p:cNvSpPr/>
+          <p:nvPr/>
+        </p:nvSpPr>
+        <p:spPr>
+          <a:xfrm>
+            <a:off x="0" y="6784848"/>
+            <a:ext cx="12191695" cy="73152"/>
+          </a:xfrm>
+          <a:prstGeom prst="rect">
+            <a:avLst/>
+          </a:prstGeom>
+          <a:solidFill>
+            <a:srgbClr val="00A3DC"/>
+          </a:solidFill>
+          <a:ln>
+            <a:noFill/>
+          </a:ln>
+        </p:spPr>
+        <p:style>
+          <a:lnRef idx="1">
+            <a:schemeClr val="accent1"/>
+          </a:lnRef>
+          <a:fillRef idx="3">
+            <a:schemeClr val="accent1"/>
+          </a:fillRef>
+          <a:effectRef idx="2">
+            <a:schemeClr val="accent1"/>
+          </a:effectRef>
+          <a:fontRef idx="minor">
+            <a:schemeClr val="lt1"/>
+          </a:fontRef>
+        </p:style>
+        <p:txBody>
+          <a:bodyPr rtlCol="0" anchor="ctr"/>
+          <a:lstStyle/>
+          <a:p>
+            <a:pPr algn="ctr"/>
+          </a:p>
+        </p:txBody>
+      </p:sp>
+      <p:sp>
+        <p:nvSpPr>
+          <p:cNvPr id="5" name="TextBox 4"/>
           <p:cNvSpPr txBox="1"/>
           <p:nvPr/>
         </p:nvSpPr>
@@ -8530,7 +9210,7 @@
       </p:sp>
       <p:sp>
         <p:nvSpPr>
-          <p:cNvPr id="5" name="TextBox 4"/>
+          <p:cNvPr id="6" name="TextBox 5"/>
           <p:cNvSpPr txBox="1"/>
           <p:nvPr/>
         </p:nvSpPr>
@@ -8558,7 +9238,7 @@
             <a:r>
               <a:rPr sz="1800" b="0">
                 <a:solidFill>
-                  <a:srgbClr val="3D4A5C"/>
+                  <a:srgbClr val="4A5568"/>
                 </a:solidFill>
                 <a:latin typeface="Arial"/>
               </a:rPr>
@@ -8569,7 +9249,7 @@
       </p:sp>
       <p:sp>
         <p:nvSpPr>
-          <p:cNvPr id="6" name="TextBox 5"/>
+          <p:cNvPr id="7" name="TextBox 6"/>
           <p:cNvSpPr txBox="1"/>
           <p:nvPr/>
         </p:nvSpPr>
@@ -8597,18 +9277,18 @@
             <a:r>
               <a:rPr sz="1200" b="0">
                 <a:solidFill>
-                  <a:srgbClr val="5B6B7C"/>
-                </a:solidFill>
-                <a:latin typeface="Arial"/>
-              </a:rPr>
-              <a:t>50+TechBridge  ·  Free Lessons  ·  Always free</a:t>
-            </a:r>
-          </a:p>
-        </p:txBody>
-      </p:sp>
-      <p:sp>
-        <p:nvSpPr>
-          <p:cNvPr id="7" name="TextBox 6"/>
+                  <a:srgbClr val="4A5568"/>
+                </a:solidFill>
+                <a:latin typeface="Arial"/>
+              </a:rPr>
+              <a:t>50+ TechBridge  ·  Free Lessons  ·  Always free</a:t>
+            </a:r>
+          </a:p>
+        </p:txBody>
+      </p:sp>
+      <p:sp>
+        <p:nvSpPr>
+          <p:cNvPr id="8" name="TextBox 7"/>
           <p:cNvSpPr txBox="1"/>
           <p:nvPr/>
         </p:nvSpPr>
@@ -8636,7 +9316,7 @@
             <a:r>
               <a:rPr sz="1200" b="0">
                 <a:solidFill>
-                  <a:srgbClr val="5B6B7C"/>
+                  <a:srgbClr val="4A5568"/>
                 </a:solidFill>
                 <a:latin typeface="Arial"/>
               </a:rPr>
@@ -8715,6 +9395,92 @@
         <p:spPr>
           <a:xfrm>
             <a:off x="0" y="0"/>
+            <a:ext cx="4206240" cy="6858000"/>
+          </a:xfrm>
+          <a:prstGeom prst="rect">
+            <a:avLst/>
+          </a:prstGeom>
+          <a:solidFill>
+            <a:srgbClr val="2B315F"/>
+          </a:solidFill>
+          <a:ln>
+            <a:noFill/>
+          </a:ln>
+        </p:spPr>
+        <p:style>
+          <a:lnRef idx="1">
+            <a:schemeClr val="accent1"/>
+          </a:lnRef>
+          <a:fillRef idx="3">
+            <a:schemeClr val="accent1"/>
+          </a:fillRef>
+          <a:effectRef idx="2">
+            <a:schemeClr val="accent1"/>
+          </a:effectRef>
+          <a:fontRef idx="minor">
+            <a:schemeClr val="lt1"/>
+          </a:fontRef>
+        </p:style>
+        <p:txBody>
+          <a:bodyPr rtlCol="0" anchor="ctr"/>
+          <a:lstStyle/>
+          <a:p>
+            <a:pPr algn="ctr"/>
+          </a:p>
+        </p:txBody>
+      </p:sp>
+      <p:sp>
+        <p:nvSpPr>
+          <p:cNvPr id="4" name="Rectangle 3"/>
+          <p:cNvSpPr/>
+          <p:nvPr/>
+        </p:nvSpPr>
+        <p:spPr>
+          <a:xfrm>
+            <a:off x="0" y="6784848"/>
+            <a:ext cx="12191695" cy="73152"/>
+          </a:xfrm>
+          <a:prstGeom prst="rect">
+            <a:avLst/>
+          </a:prstGeom>
+          <a:solidFill>
+            <a:srgbClr val="00A3DC"/>
+          </a:solidFill>
+          <a:ln>
+            <a:noFill/>
+          </a:ln>
+        </p:spPr>
+        <p:style>
+          <a:lnRef idx="1">
+            <a:schemeClr val="accent1"/>
+          </a:lnRef>
+          <a:fillRef idx="3">
+            <a:schemeClr val="accent1"/>
+          </a:fillRef>
+          <a:effectRef idx="2">
+            <a:schemeClr val="accent1"/>
+          </a:effectRef>
+          <a:fontRef idx="minor">
+            <a:schemeClr val="lt1"/>
+          </a:fontRef>
+        </p:style>
+        <p:txBody>
+          <a:bodyPr rtlCol="0" anchor="ctr"/>
+          <a:lstStyle/>
+          <a:p>
+            <a:pPr algn="ctr"/>
+          </a:p>
+        </p:txBody>
+      </p:sp>
+      <p:sp>
+        <p:nvSpPr>
+          <p:cNvPr id="5" name="Rectangle 4"/>
+          <p:cNvSpPr/>
+          <p:nvPr/>
+        </p:nvSpPr>
+        <p:spPr>
+          <a:xfrm>
+            <a:off x="0" y="0"/>
             <a:ext cx="12191695" cy="109728"/>
           </a:xfrm>
           <a:prstGeom prst="rect">
@@ -8751,7 +9517,7 @@
       </p:sp>
       <p:sp>
         <p:nvSpPr>
-          <p:cNvPr id="4" name="TextBox 3"/>
+          <p:cNvPr id="6" name="TextBox 5"/>
           <p:cNvSpPr txBox="1"/>
           <p:nvPr/>
         </p:nvSpPr>
@@ -8806,7 +9572,7 @@
       </p:sp>
       <p:sp>
         <p:nvSpPr>
-          <p:cNvPr id="5" name="Rectangle 4"/>
+          <p:cNvPr id="7" name="Rectangle 6"/>
           <p:cNvSpPr/>
           <p:nvPr/>
         </p:nvSpPr>
@@ -8849,7 +9615,7 @@
       </p:sp>
       <p:sp>
         <p:nvSpPr>
-          <p:cNvPr id="6" name="TextBox 5"/>
+          <p:cNvPr id="8" name="TextBox 7"/>
           <p:cNvSpPr txBox="1"/>
           <p:nvPr/>
         </p:nvSpPr>
@@ -8936,7 +9702,7 @@
       </p:sp>
       <p:sp>
         <p:nvSpPr>
-          <p:cNvPr id="7" name="TextBox 6"/>
+          <p:cNvPr id="9" name="TextBox 8"/>
           <p:cNvSpPr txBox="1"/>
           <p:nvPr/>
         </p:nvSpPr>
@@ -8964,18 +9730,18 @@
             <a:r>
               <a:rPr sz="1200" b="0">
                 <a:solidFill>
-                  <a:srgbClr val="9AB0C0"/>
-                </a:solidFill>
-                <a:latin typeface="Arial"/>
-              </a:rPr>
-              <a:t>50+TechBridge  ·  Free Lessons  ·  Always free</a:t>
-            </a:r>
-          </a:p>
-        </p:txBody>
-      </p:sp>
-      <p:sp>
-        <p:nvSpPr>
-          <p:cNvPr id="8" name="TextBox 7"/>
+                  <a:srgbClr val="C8DFF0"/>
+                </a:solidFill>
+                <a:latin typeface="Arial"/>
+              </a:rPr>
+              <a:t>50+ TechBridge  ·  Free Lessons  ·  Always free</a:t>
+            </a:r>
+          </a:p>
+        </p:txBody>
+      </p:sp>
+      <p:sp>
+        <p:nvSpPr>
+          <p:cNvPr id="10" name="TextBox 9"/>
           <p:cNvSpPr txBox="1"/>
           <p:nvPr/>
         </p:nvSpPr>
@@ -9003,7 +9769,7 @@
             <a:r>
               <a:rPr sz="1200" b="0">
                 <a:solidFill>
-                  <a:srgbClr val="9AB0C0"/>
+                  <a:srgbClr val="C8DFF0"/>
                 </a:solidFill>
                 <a:latin typeface="Arial"/>
               </a:rPr>
@@ -9045,7 +9811,7 @@
             <a:avLst/>
           </a:prstGeom>
           <a:solidFill>
-            <a:srgbClr val="F7F4EF"/>
+            <a:srgbClr val="FFFFFF"/>
           </a:solidFill>
           <a:ln>
             <a:noFill/>
@@ -9118,7 +9884,50 @@
       </p:sp>
       <p:sp>
         <p:nvSpPr>
-          <p:cNvPr id="4" name="TextBox 3"/>
+          <p:cNvPr id="4" name="Rectangle 3"/>
+          <p:cNvSpPr/>
+          <p:nvPr/>
+        </p:nvSpPr>
+        <p:spPr>
+          <a:xfrm>
+            <a:off x="0" y="6784848"/>
+            <a:ext cx="12191695" cy="73152"/>
+          </a:xfrm>
+          <a:prstGeom prst="rect">
+            <a:avLst/>
+          </a:prstGeom>
+          <a:solidFill>
+            <a:srgbClr val="00A3DC"/>
+          </a:solidFill>
+          <a:ln>
+            <a:noFill/>
+          </a:ln>
+        </p:spPr>
+        <p:style>
+          <a:lnRef idx="1">
+            <a:schemeClr val="accent1"/>
+          </a:lnRef>
+          <a:fillRef idx="3">
+            <a:schemeClr val="accent1"/>
+          </a:fillRef>
+          <a:effectRef idx="2">
+            <a:schemeClr val="accent1"/>
+          </a:effectRef>
+          <a:fontRef idx="minor">
+            <a:schemeClr val="lt1"/>
+          </a:fontRef>
+        </p:style>
+        <p:txBody>
+          <a:bodyPr rtlCol="0" anchor="ctr"/>
+          <a:lstStyle/>
+          <a:p>
+            <a:pPr algn="ctr"/>
+          </a:p>
+        </p:txBody>
+      </p:sp>
+      <p:sp>
+        <p:nvSpPr>
+          <p:cNvPr id="5" name="TextBox 4"/>
           <p:cNvSpPr txBox="1"/>
           <p:nvPr/>
         </p:nvSpPr>
@@ -9157,7 +9966,7 @@
       </p:sp>
       <p:sp>
         <p:nvSpPr>
-          <p:cNvPr id="5" name="Rectangle 4"/>
+          <p:cNvPr id="6" name="Rectangle 5"/>
           <p:cNvSpPr/>
           <p:nvPr/>
         </p:nvSpPr>
@@ -9200,7 +10009,7 @@
       </p:sp>
       <p:sp>
         <p:nvSpPr>
-          <p:cNvPr id="6" name="TextBox 5"/>
+          <p:cNvPr id="7" name="TextBox 6"/>
           <p:cNvSpPr txBox="1"/>
           <p:nvPr/>
         </p:nvSpPr>
@@ -9303,7 +10112,7 @@
       </p:sp>
       <p:sp>
         <p:nvSpPr>
-          <p:cNvPr id="7" name="Rectangle 6"/>
+          <p:cNvPr id="8" name="Rectangle 7"/>
           <p:cNvSpPr/>
           <p:nvPr/>
         </p:nvSpPr>
@@ -9346,7 +10155,7 @@
       </p:sp>
       <p:sp>
         <p:nvSpPr>
-          <p:cNvPr id="8" name="TextBox 7"/>
+          <p:cNvPr id="9" name="TextBox 8"/>
           <p:cNvSpPr txBox="1"/>
           <p:nvPr/>
         </p:nvSpPr>
@@ -9449,7 +10258,7 @@
       </p:sp>
       <p:sp>
         <p:nvSpPr>
-          <p:cNvPr id="9" name="TextBox 8"/>
+          <p:cNvPr id="10" name="TextBox 9"/>
           <p:cNvSpPr txBox="1"/>
           <p:nvPr/>
         </p:nvSpPr>
@@ -9477,18 +10286,18 @@
             <a:r>
               <a:rPr sz="1200" b="0">
                 <a:solidFill>
-                  <a:srgbClr val="5B6B7C"/>
-                </a:solidFill>
-                <a:latin typeface="Arial"/>
-              </a:rPr>
-              <a:t>50+TechBridge  ·  Free Lessons  ·  Always free</a:t>
-            </a:r>
-          </a:p>
-        </p:txBody>
-      </p:sp>
-      <p:sp>
-        <p:nvSpPr>
-          <p:cNvPr id="10" name="TextBox 9"/>
+                  <a:srgbClr val="4A5568"/>
+                </a:solidFill>
+                <a:latin typeface="Arial"/>
+              </a:rPr>
+              <a:t>50+ TechBridge  ·  Free Lessons  ·  Always free</a:t>
+            </a:r>
+          </a:p>
+        </p:txBody>
+      </p:sp>
+      <p:sp>
+        <p:nvSpPr>
+          <p:cNvPr id="11" name="TextBox 10"/>
           <p:cNvSpPr txBox="1"/>
           <p:nvPr/>
         </p:nvSpPr>
@@ -9516,7 +10325,7 @@
             <a:r>
               <a:rPr sz="1200" b="0">
                 <a:solidFill>
-                  <a:srgbClr val="5B6B7C"/>
+                  <a:srgbClr val="4A5568"/>
                 </a:solidFill>
                 <a:latin typeface="Arial"/>
               </a:rPr>
@@ -9558,7 +10367,7 @@
             <a:avLst/>
           </a:prstGeom>
           <a:solidFill>
-            <a:srgbClr val="F7F4EF"/>
+            <a:srgbClr val="FFFFFF"/>
           </a:solidFill>
           <a:ln>
             <a:noFill/>
@@ -9631,7 +10440,50 @@
       </p:sp>
       <p:sp>
         <p:nvSpPr>
-          <p:cNvPr id="4" name="TextBox 3"/>
+          <p:cNvPr id="4" name="Rectangle 3"/>
+          <p:cNvSpPr/>
+          <p:nvPr/>
+        </p:nvSpPr>
+        <p:spPr>
+          <a:xfrm>
+            <a:off x="0" y="6784848"/>
+            <a:ext cx="12191695" cy="73152"/>
+          </a:xfrm>
+          <a:prstGeom prst="rect">
+            <a:avLst/>
+          </a:prstGeom>
+          <a:solidFill>
+            <a:srgbClr val="00A3DC"/>
+          </a:solidFill>
+          <a:ln>
+            <a:noFill/>
+          </a:ln>
+        </p:spPr>
+        <p:style>
+          <a:lnRef idx="1">
+            <a:schemeClr val="accent1"/>
+          </a:lnRef>
+          <a:fillRef idx="3">
+            <a:schemeClr val="accent1"/>
+          </a:fillRef>
+          <a:effectRef idx="2">
+            <a:schemeClr val="accent1"/>
+          </a:effectRef>
+          <a:fontRef idx="minor">
+            <a:schemeClr val="lt1"/>
+          </a:fontRef>
+        </p:style>
+        <p:txBody>
+          <a:bodyPr rtlCol="0" anchor="ctr"/>
+          <a:lstStyle/>
+          <a:p>
+            <a:pPr algn="ctr"/>
+          </a:p>
+        </p:txBody>
+      </p:sp>
+      <p:sp>
+        <p:nvSpPr>
+          <p:cNvPr id="5" name="TextBox 4"/>
           <p:cNvSpPr txBox="1"/>
           <p:nvPr/>
         </p:nvSpPr>
@@ -9670,7 +10522,7 @@
       </p:sp>
       <p:sp>
         <p:nvSpPr>
-          <p:cNvPr id="5" name="TextBox 4"/>
+          <p:cNvPr id="6" name="TextBox 5"/>
           <p:cNvSpPr txBox="1"/>
           <p:nvPr/>
         </p:nvSpPr>
@@ -9698,7 +10550,7 @@
             <a:r>
               <a:rPr sz="2400" b="0">
                 <a:solidFill>
-                  <a:srgbClr val="3D4A5C"/>
+                  <a:srgbClr val="4A5568"/>
                 </a:solidFill>
                 <a:latin typeface="Arial"/>
               </a:rPr>
@@ -9714,7 +10566,7 @@
             <a:r>
               <a:rPr sz="2400" b="0">
                 <a:solidFill>
-                  <a:srgbClr val="3D4A5C"/>
+                  <a:srgbClr val="4A5568"/>
                 </a:solidFill>
                 <a:latin typeface="Arial"/>
               </a:rPr>
@@ -9730,7 +10582,7 @@
             <a:r>
               <a:rPr sz="2400" b="0">
                 <a:solidFill>
-                  <a:srgbClr val="3D4A5C"/>
+                  <a:srgbClr val="4A5568"/>
                 </a:solidFill>
                 <a:latin typeface="Arial"/>
               </a:rPr>
@@ -9746,7 +10598,7 @@
             <a:r>
               <a:rPr sz="2400" b="0">
                 <a:solidFill>
-                  <a:srgbClr val="3D4A5C"/>
+                  <a:srgbClr val="4A5568"/>
                 </a:solidFill>
                 <a:latin typeface="Arial"/>
               </a:rPr>
@@ -9762,7 +10614,7 @@
             <a:r>
               <a:rPr sz="2400" b="0">
                 <a:solidFill>
-                  <a:srgbClr val="3D4A5C"/>
+                  <a:srgbClr val="4A5568"/>
                 </a:solidFill>
                 <a:latin typeface="Arial"/>
               </a:rPr>
@@ -9778,7 +10630,7 @@
             <a:r>
               <a:rPr sz="2400" b="0">
                 <a:solidFill>
-                  <a:srgbClr val="3D4A5C"/>
+                  <a:srgbClr val="4A5568"/>
                 </a:solidFill>
                 <a:latin typeface="Arial"/>
               </a:rPr>
@@ -9789,7 +10641,7 @@
       </p:sp>
       <p:sp>
         <p:nvSpPr>
-          <p:cNvPr id="6" name="TextBox 5"/>
+          <p:cNvPr id="7" name="TextBox 6"/>
           <p:cNvSpPr txBox="1"/>
           <p:nvPr/>
         </p:nvSpPr>
@@ -9817,18 +10669,18 @@
             <a:r>
               <a:rPr sz="1200" b="0">
                 <a:solidFill>
-                  <a:srgbClr val="5B6B7C"/>
-                </a:solidFill>
-                <a:latin typeface="Arial"/>
-              </a:rPr>
-              <a:t>50+TechBridge  ·  Free Lessons  ·  Always free</a:t>
-            </a:r>
-          </a:p>
-        </p:txBody>
-      </p:sp>
-      <p:sp>
-        <p:nvSpPr>
-          <p:cNvPr id="7" name="TextBox 6"/>
+                  <a:srgbClr val="4A5568"/>
+                </a:solidFill>
+                <a:latin typeface="Arial"/>
+              </a:rPr>
+              <a:t>50+ TechBridge  ·  Free Lessons  ·  Always free</a:t>
+            </a:r>
+          </a:p>
+        </p:txBody>
+      </p:sp>
+      <p:sp>
+        <p:nvSpPr>
+          <p:cNvPr id="8" name="TextBox 7"/>
           <p:cNvSpPr txBox="1"/>
           <p:nvPr/>
         </p:nvSpPr>
@@ -9856,7 +10708,7 @@
             <a:r>
               <a:rPr sz="1200" b="0">
                 <a:solidFill>
-                  <a:srgbClr val="5B6B7C"/>
+                  <a:srgbClr val="4A5568"/>
                 </a:solidFill>
                 <a:latin typeface="Arial"/>
               </a:rPr>
@@ -9898,7 +10750,7 @@
             <a:avLst/>
           </a:prstGeom>
           <a:solidFill>
-            <a:srgbClr val="F7F4EF"/>
+            <a:srgbClr val="FFFFFF"/>
           </a:solidFill>
           <a:ln>
             <a:noFill/>
@@ -9971,7 +10823,50 @@
       </p:sp>
       <p:sp>
         <p:nvSpPr>
-          <p:cNvPr id="4" name="TextBox 3"/>
+          <p:cNvPr id="4" name="Rectangle 3"/>
+          <p:cNvSpPr/>
+          <p:nvPr/>
+        </p:nvSpPr>
+        <p:spPr>
+          <a:xfrm>
+            <a:off x="0" y="6784848"/>
+            <a:ext cx="12191695" cy="73152"/>
+          </a:xfrm>
+          <a:prstGeom prst="rect">
+            <a:avLst/>
+          </a:prstGeom>
+          <a:solidFill>
+            <a:srgbClr val="00A3DC"/>
+          </a:solidFill>
+          <a:ln>
+            <a:noFill/>
+          </a:ln>
+        </p:spPr>
+        <p:style>
+          <a:lnRef idx="1">
+            <a:schemeClr val="accent1"/>
+          </a:lnRef>
+          <a:fillRef idx="3">
+            <a:schemeClr val="accent1"/>
+          </a:fillRef>
+          <a:effectRef idx="2">
+            <a:schemeClr val="accent1"/>
+          </a:effectRef>
+          <a:fontRef idx="minor">
+            <a:schemeClr val="lt1"/>
+          </a:fontRef>
+        </p:style>
+        <p:txBody>
+          <a:bodyPr rtlCol="0" anchor="ctr"/>
+          <a:lstStyle/>
+          <a:p>
+            <a:pPr algn="ctr"/>
+          </a:p>
+        </p:txBody>
+      </p:sp>
+      <p:sp>
+        <p:nvSpPr>
+          <p:cNvPr id="5" name="TextBox 4"/>
           <p:cNvSpPr txBox="1"/>
           <p:nvPr/>
         </p:nvSpPr>
@@ -10015,7 +10910,7 @@
             <a:r>
               <a:rPr sz="1800" b="0">
                 <a:solidFill>
-                  <a:srgbClr val="3D4A5C"/>
+                  <a:srgbClr val="4A5568"/>
                 </a:solidFill>
                 <a:latin typeface="Arial"/>
               </a:rPr>
@@ -10026,7 +10921,7 @@
       </p:sp>
       <p:sp>
         <p:nvSpPr>
-          <p:cNvPr id="5" name="Rectangle 4"/>
+          <p:cNvPr id="6" name="Rectangle 5"/>
           <p:cNvSpPr/>
           <p:nvPr/>
         </p:nvSpPr>
@@ -10069,7 +10964,7 @@
       </p:sp>
       <p:sp>
         <p:nvSpPr>
-          <p:cNvPr id="6" name="TextBox 5"/>
+          <p:cNvPr id="7" name="TextBox 6"/>
           <p:cNvSpPr txBox="1"/>
           <p:nvPr/>
         </p:nvSpPr>
@@ -10108,7 +11003,7 @@
       </p:sp>
       <p:sp>
         <p:nvSpPr>
-          <p:cNvPr id="7" name="TextBox 6"/>
+          <p:cNvPr id="8" name="TextBox 7"/>
           <p:cNvSpPr txBox="1"/>
           <p:nvPr/>
         </p:nvSpPr>
@@ -10149,7 +11044,7 @@
       </p:sp>
       <p:sp>
         <p:nvSpPr>
-          <p:cNvPr id="8" name="Rectangle 7"/>
+          <p:cNvPr id="9" name="Rectangle 8"/>
           <p:cNvSpPr/>
           <p:nvPr/>
         </p:nvSpPr>
@@ -10192,7 +11087,7 @@
       </p:sp>
       <p:sp>
         <p:nvSpPr>
-          <p:cNvPr id="9" name="TextBox 8"/>
+          <p:cNvPr id="10" name="TextBox 9"/>
           <p:cNvSpPr txBox="1"/>
           <p:nvPr/>
         </p:nvSpPr>
@@ -10231,7 +11126,7 @@
       </p:sp>
       <p:sp>
         <p:nvSpPr>
-          <p:cNvPr id="10" name="TextBox 9"/>
+          <p:cNvPr id="11" name="TextBox 10"/>
           <p:cNvSpPr txBox="1"/>
           <p:nvPr/>
         </p:nvSpPr>
@@ -10272,7 +11167,7 @@
       </p:sp>
       <p:sp>
         <p:nvSpPr>
-          <p:cNvPr id="11" name="Rectangle 10"/>
+          <p:cNvPr id="12" name="Rectangle 11"/>
           <p:cNvSpPr/>
           <p:nvPr/>
         </p:nvSpPr>
@@ -10315,7 +11210,7 @@
       </p:sp>
       <p:sp>
         <p:nvSpPr>
-          <p:cNvPr id="12" name="TextBox 11"/>
+          <p:cNvPr id="13" name="TextBox 12"/>
           <p:cNvSpPr txBox="1"/>
           <p:nvPr/>
         </p:nvSpPr>
@@ -10354,7 +11249,7 @@
       </p:sp>
       <p:sp>
         <p:nvSpPr>
-          <p:cNvPr id="13" name="TextBox 12"/>
+          <p:cNvPr id="14" name="TextBox 13"/>
           <p:cNvSpPr txBox="1"/>
           <p:nvPr/>
         </p:nvSpPr>
@@ -10395,7 +11290,7 @@
       </p:sp>
       <p:sp>
         <p:nvSpPr>
-          <p:cNvPr id="14" name="TextBox 13"/>
+          <p:cNvPr id="15" name="TextBox 14"/>
           <p:cNvSpPr txBox="1"/>
           <p:nvPr/>
         </p:nvSpPr>
@@ -10423,18 +11318,18 @@
             <a:r>
               <a:rPr sz="1200" b="0">
                 <a:solidFill>
-                  <a:srgbClr val="5B6B7C"/>
-                </a:solidFill>
-                <a:latin typeface="Arial"/>
-              </a:rPr>
-              <a:t>50+TechBridge  ·  Free Lessons  ·  Always free</a:t>
-            </a:r>
-          </a:p>
-        </p:txBody>
-      </p:sp>
-      <p:sp>
-        <p:nvSpPr>
-          <p:cNvPr id="15" name="TextBox 14"/>
+                  <a:srgbClr val="4A5568"/>
+                </a:solidFill>
+                <a:latin typeface="Arial"/>
+              </a:rPr>
+              <a:t>50+ TechBridge  ·  Free Lessons  ·  Always free</a:t>
+            </a:r>
+          </a:p>
+        </p:txBody>
+      </p:sp>
+      <p:sp>
+        <p:nvSpPr>
+          <p:cNvPr id="16" name="TextBox 15"/>
           <p:cNvSpPr txBox="1"/>
           <p:nvPr/>
         </p:nvSpPr>
@@ -10462,7 +11357,7 @@
             <a:r>
               <a:rPr sz="1200" b="0">
                 <a:solidFill>
-                  <a:srgbClr val="5B6B7C"/>
+                  <a:srgbClr val="4A5568"/>
                 </a:solidFill>
                 <a:latin typeface="Arial"/>
               </a:rPr>
@@ -10541,6 +11436,92 @@
         <p:spPr>
           <a:xfrm>
             <a:off x="0" y="0"/>
+            <a:ext cx="4206240" cy="6858000"/>
+          </a:xfrm>
+          <a:prstGeom prst="rect">
+            <a:avLst/>
+          </a:prstGeom>
+          <a:solidFill>
+            <a:srgbClr val="2B315F"/>
+          </a:solidFill>
+          <a:ln>
+            <a:noFill/>
+          </a:ln>
+        </p:spPr>
+        <p:style>
+          <a:lnRef idx="1">
+            <a:schemeClr val="accent1"/>
+          </a:lnRef>
+          <a:fillRef idx="3">
+            <a:schemeClr val="accent1"/>
+          </a:fillRef>
+          <a:effectRef idx="2">
+            <a:schemeClr val="accent1"/>
+          </a:effectRef>
+          <a:fontRef idx="minor">
+            <a:schemeClr val="lt1"/>
+          </a:fontRef>
+        </p:style>
+        <p:txBody>
+          <a:bodyPr rtlCol="0" anchor="ctr"/>
+          <a:lstStyle/>
+          <a:p>
+            <a:pPr algn="ctr"/>
+          </a:p>
+        </p:txBody>
+      </p:sp>
+      <p:sp>
+        <p:nvSpPr>
+          <p:cNvPr id="4" name="Rectangle 3"/>
+          <p:cNvSpPr/>
+          <p:nvPr/>
+        </p:nvSpPr>
+        <p:spPr>
+          <a:xfrm>
+            <a:off x="0" y="6784848"/>
+            <a:ext cx="12191695" cy="73152"/>
+          </a:xfrm>
+          <a:prstGeom prst="rect">
+            <a:avLst/>
+          </a:prstGeom>
+          <a:solidFill>
+            <a:srgbClr val="00A3DC"/>
+          </a:solidFill>
+          <a:ln>
+            <a:noFill/>
+          </a:ln>
+        </p:spPr>
+        <p:style>
+          <a:lnRef idx="1">
+            <a:schemeClr val="accent1"/>
+          </a:lnRef>
+          <a:fillRef idx="3">
+            <a:schemeClr val="accent1"/>
+          </a:fillRef>
+          <a:effectRef idx="2">
+            <a:schemeClr val="accent1"/>
+          </a:effectRef>
+          <a:fontRef idx="minor">
+            <a:schemeClr val="lt1"/>
+          </a:fontRef>
+        </p:style>
+        <p:txBody>
+          <a:bodyPr rtlCol="0" anchor="ctr"/>
+          <a:lstStyle/>
+          <a:p>
+            <a:pPr algn="ctr"/>
+          </a:p>
+        </p:txBody>
+      </p:sp>
+      <p:sp>
+        <p:nvSpPr>
+          <p:cNvPr id="5" name="Rectangle 4"/>
+          <p:cNvSpPr/>
+          <p:nvPr/>
+        </p:nvSpPr>
+        <p:spPr>
+          <a:xfrm>
+            <a:off x="0" y="0"/>
             <a:ext cx="12191695" cy="109728"/>
           </a:xfrm>
           <a:prstGeom prst="rect">
@@ -10577,7 +11558,7 @@
       </p:sp>
       <p:sp>
         <p:nvSpPr>
-          <p:cNvPr id="4" name="TextBox 3"/>
+          <p:cNvPr id="6" name="TextBox 5"/>
           <p:cNvSpPr txBox="1"/>
           <p:nvPr/>
         </p:nvSpPr>
@@ -10616,7 +11597,7 @@
       </p:sp>
       <p:sp>
         <p:nvSpPr>
-          <p:cNvPr id="5" name="TextBox 4"/>
+          <p:cNvPr id="7" name="TextBox 6"/>
           <p:cNvSpPr txBox="1"/>
           <p:nvPr/>
         </p:nvSpPr>
@@ -10687,7 +11668,7 @@
       </p:sp>
       <p:sp>
         <p:nvSpPr>
-          <p:cNvPr id="6" name="TextBox 5"/>
+          <p:cNvPr id="8" name="TextBox 7"/>
           <p:cNvSpPr txBox="1"/>
           <p:nvPr/>
         </p:nvSpPr>
@@ -10715,18 +11696,18 @@
             <a:r>
               <a:rPr sz="1200" b="0">
                 <a:solidFill>
-                  <a:srgbClr val="9AB0C0"/>
-                </a:solidFill>
-                <a:latin typeface="Arial"/>
-              </a:rPr>
-              <a:t>50+TechBridge  ·  Free Lessons  ·  Always free</a:t>
-            </a:r>
-          </a:p>
-        </p:txBody>
-      </p:sp>
-      <p:sp>
-        <p:nvSpPr>
-          <p:cNvPr id="7" name="TextBox 6"/>
+                  <a:srgbClr val="C8DFF0"/>
+                </a:solidFill>
+                <a:latin typeface="Arial"/>
+              </a:rPr>
+              <a:t>50+ TechBridge  ·  Free Lessons  ·  Always free</a:t>
+            </a:r>
+          </a:p>
+        </p:txBody>
+      </p:sp>
+      <p:sp>
+        <p:nvSpPr>
+          <p:cNvPr id="9" name="TextBox 8"/>
           <p:cNvSpPr txBox="1"/>
           <p:nvPr/>
         </p:nvSpPr>
@@ -10754,7 +11735,7 @@
             <a:r>
               <a:rPr sz="1200" b="0">
                 <a:solidFill>
-                  <a:srgbClr val="9AB0C0"/>
+                  <a:srgbClr val="C8DFF0"/>
                 </a:solidFill>
                 <a:latin typeface="Arial"/>
               </a:rPr>
@@ -10796,7 +11777,7 @@
             <a:avLst/>
           </a:prstGeom>
           <a:solidFill>
-            <a:srgbClr val="F7F4EF"/>
+            <a:srgbClr val="FFFFFF"/>
           </a:solidFill>
           <a:ln>
             <a:noFill/>
@@ -10869,59 +11850,20 @@
       </p:sp>
       <p:sp>
         <p:nvSpPr>
-          <p:cNvPr id="4" name="TextBox 3"/>
-          <p:cNvSpPr txBox="1"/>
-          <p:nvPr/>
-        </p:nvSpPr>
-        <p:spPr>
-          <a:xfrm>
-            <a:off x="548640" y="320040"/>
-            <a:ext cx="10972800" cy="640080"/>
-          </a:xfrm>
-          <a:prstGeom prst="rect">
-            <a:avLst/>
-          </a:prstGeom>
-          <a:noFill/>
-        </p:spPr>
-        <p:txBody>
-          <a:bodyPr wrap="square">
-            <a:spAutoFit/>
-          </a:bodyPr>
-          <a:lstStyle/>
-          <a:p>
-            <a:pPr algn="l">
-              <a:spcAft>
-                <a:spcPts val="800"/>
-              </a:spcAft>
-            </a:pPr>
-            <a:r>
-              <a:rPr sz="3400" b="1">
-                <a:solidFill>
-                  <a:srgbClr val="083655"/>
-                </a:solidFill>
-                <a:latin typeface="Arial"/>
-              </a:rPr>
-              <a:t>Do this today</a:t>
-            </a:r>
-          </a:p>
-        </p:txBody>
-      </p:sp>
-      <p:sp>
-        <p:nvSpPr>
-          <p:cNvPr id="5" name="Rectangle 4"/>
+          <p:cNvPr id="4" name="Rectangle 3"/>
           <p:cNvSpPr/>
           <p:nvPr/>
         </p:nvSpPr>
         <p:spPr>
           <a:xfrm>
-            <a:off x="548640" y="1143000"/>
-            <a:ext cx="11064240" cy="1024128"/>
+            <a:off x="0" y="6784848"/>
+            <a:ext cx="12191695" cy="73152"/>
           </a:xfrm>
           <a:prstGeom prst="rect">
             <a:avLst/>
           </a:prstGeom>
           <a:solidFill>
-            <a:srgbClr val="FFFFFF"/>
+            <a:srgbClr val="00A3DC"/>
           </a:solidFill>
           <a:ln>
             <a:noFill/>
@@ -10951,7 +11893,89 @@
       </p:sp>
       <p:sp>
         <p:nvSpPr>
+          <p:cNvPr id="5" name="TextBox 4"/>
+          <p:cNvSpPr txBox="1"/>
+          <p:nvPr/>
+        </p:nvSpPr>
+        <p:spPr>
+          <a:xfrm>
+            <a:off x="548640" y="320040"/>
+            <a:ext cx="10972800" cy="640080"/>
+          </a:xfrm>
+          <a:prstGeom prst="rect">
+            <a:avLst/>
+          </a:prstGeom>
+          <a:noFill/>
+        </p:spPr>
+        <p:txBody>
+          <a:bodyPr wrap="square">
+            <a:spAutoFit/>
+          </a:bodyPr>
+          <a:lstStyle/>
+          <a:p>
+            <a:pPr algn="l">
+              <a:spcAft>
+                <a:spcPts val="800"/>
+              </a:spcAft>
+            </a:pPr>
+            <a:r>
+              <a:rPr sz="3400" b="1">
+                <a:solidFill>
+                  <a:srgbClr val="083655"/>
+                </a:solidFill>
+                <a:latin typeface="Arial"/>
+              </a:rPr>
+              <a:t>Do this today</a:t>
+            </a:r>
+          </a:p>
+        </p:txBody>
+      </p:sp>
+      <p:sp>
+        <p:nvSpPr>
           <p:cNvPr id="6" name="Rectangle 5"/>
+          <p:cNvSpPr/>
+          <p:nvPr/>
+        </p:nvSpPr>
+        <p:spPr>
+          <a:xfrm>
+            <a:off x="548640" y="1143000"/>
+            <a:ext cx="11064240" cy="1024128"/>
+          </a:xfrm>
+          <a:prstGeom prst="rect">
+            <a:avLst/>
+          </a:prstGeom>
+          <a:solidFill>
+            <a:srgbClr val="F0F8FF"/>
+          </a:solidFill>
+          <a:ln>
+            <a:noFill/>
+          </a:ln>
+        </p:spPr>
+        <p:style>
+          <a:lnRef idx="1">
+            <a:schemeClr val="accent1"/>
+          </a:lnRef>
+          <a:fillRef idx="3">
+            <a:schemeClr val="accent1"/>
+          </a:fillRef>
+          <a:effectRef idx="2">
+            <a:schemeClr val="accent1"/>
+          </a:effectRef>
+          <a:fontRef idx="minor">
+            <a:schemeClr val="lt1"/>
+          </a:fontRef>
+        </p:style>
+        <p:txBody>
+          <a:bodyPr rtlCol="0" anchor="ctr"/>
+          <a:lstStyle/>
+          <a:p>
+            <a:pPr algn="ctr"/>
+          </a:p>
+        </p:txBody>
+      </p:sp>
+      <p:sp>
+        <p:nvSpPr>
+          <p:cNvPr id="7" name="Rectangle 6"/>
           <p:cNvSpPr/>
           <p:nvPr/>
         </p:nvSpPr>
@@ -10994,7 +12018,7 @@
       </p:sp>
       <p:sp>
         <p:nvSpPr>
-          <p:cNvPr id="7" name="TextBox 6"/>
+          <p:cNvPr id="8" name="TextBox 7"/>
           <p:cNvSpPr txBox="1"/>
           <p:nvPr/>
         </p:nvSpPr>
@@ -11033,7 +12057,7 @@
       </p:sp>
       <p:sp>
         <p:nvSpPr>
-          <p:cNvPr id="8" name="TextBox 7"/>
+          <p:cNvPr id="9" name="TextBox 8"/>
           <p:cNvSpPr txBox="1"/>
           <p:nvPr/>
         </p:nvSpPr>
@@ -11072,7 +12096,7 @@
       </p:sp>
       <p:sp>
         <p:nvSpPr>
-          <p:cNvPr id="9" name="Rectangle 8"/>
+          <p:cNvPr id="10" name="Rectangle 9"/>
           <p:cNvSpPr/>
           <p:nvPr/>
         </p:nvSpPr>
@@ -11085,7 +12109,7 @@
             <a:avLst/>
           </a:prstGeom>
           <a:solidFill>
-            <a:srgbClr val="FFFFFF"/>
+            <a:srgbClr val="F0F8FF"/>
           </a:solidFill>
           <a:ln>
             <a:noFill/>
@@ -11115,7 +12139,7 @@
       </p:sp>
       <p:sp>
         <p:nvSpPr>
-          <p:cNvPr id="10" name="Rectangle 9"/>
+          <p:cNvPr id="11" name="Rectangle 10"/>
           <p:cNvSpPr/>
           <p:nvPr/>
         </p:nvSpPr>
@@ -11158,7 +12182,7 @@
       </p:sp>
       <p:sp>
         <p:nvSpPr>
-          <p:cNvPr id="11" name="TextBox 10"/>
+          <p:cNvPr id="12" name="TextBox 11"/>
           <p:cNvSpPr txBox="1"/>
           <p:nvPr/>
         </p:nvSpPr>
@@ -11197,7 +12221,7 @@
       </p:sp>
       <p:sp>
         <p:nvSpPr>
-          <p:cNvPr id="12" name="TextBox 11"/>
+          <p:cNvPr id="13" name="TextBox 12"/>
           <p:cNvSpPr txBox="1"/>
           <p:nvPr/>
         </p:nvSpPr>
@@ -11236,7 +12260,7 @@
       </p:sp>
       <p:sp>
         <p:nvSpPr>
-          <p:cNvPr id="13" name="Rectangle 12"/>
+          <p:cNvPr id="14" name="Rectangle 13"/>
           <p:cNvSpPr/>
           <p:nvPr/>
         </p:nvSpPr>
@@ -11249,7 +12273,7 @@
             <a:avLst/>
           </a:prstGeom>
           <a:solidFill>
-            <a:srgbClr val="FFFFFF"/>
+            <a:srgbClr val="F0F8FF"/>
           </a:solidFill>
           <a:ln>
             <a:noFill/>
@@ -11279,7 +12303,7 @@
       </p:sp>
       <p:sp>
         <p:nvSpPr>
-          <p:cNvPr id="14" name="Rectangle 13"/>
+          <p:cNvPr id="15" name="Rectangle 14"/>
           <p:cNvSpPr/>
           <p:nvPr/>
         </p:nvSpPr>
@@ -11322,7 +12346,7 @@
       </p:sp>
       <p:sp>
         <p:nvSpPr>
-          <p:cNvPr id="15" name="TextBox 14"/>
+          <p:cNvPr id="16" name="TextBox 15"/>
           <p:cNvSpPr txBox="1"/>
           <p:nvPr/>
         </p:nvSpPr>
@@ -11361,7 +12385,7 @@
       </p:sp>
       <p:sp>
         <p:nvSpPr>
-          <p:cNvPr id="16" name="TextBox 15"/>
+          <p:cNvPr id="17" name="TextBox 16"/>
           <p:cNvSpPr txBox="1"/>
           <p:nvPr/>
         </p:nvSpPr>
@@ -11400,7 +12424,7 @@
       </p:sp>
       <p:sp>
         <p:nvSpPr>
-          <p:cNvPr id="17" name="Rectangle 16"/>
+          <p:cNvPr id="18" name="Rectangle 17"/>
           <p:cNvSpPr/>
           <p:nvPr/>
         </p:nvSpPr>
@@ -11413,7 +12437,7 @@
             <a:avLst/>
           </a:prstGeom>
           <a:solidFill>
-            <a:srgbClr val="FFFFFF"/>
+            <a:srgbClr val="F0F8FF"/>
           </a:solidFill>
           <a:ln>
             <a:noFill/>
@@ -11443,7 +12467,7 @@
       </p:sp>
       <p:sp>
         <p:nvSpPr>
-          <p:cNvPr id="18" name="Rectangle 17"/>
+          <p:cNvPr id="19" name="Rectangle 18"/>
           <p:cNvSpPr/>
           <p:nvPr/>
         </p:nvSpPr>
@@ -11486,7 +12510,7 @@
       </p:sp>
       <p:sp>
         <p:nvSpPr>
-          <p:cNvPr id="19" name="TextBox 18"/>
+          <p:cNvPr id="20" name="TextBox 19"/>
           <p:cNvSpPr txBox="1"/>
           <p:nvPr/>
         </p:nvSpPr>
@@ -11525,7 +12549,7 @@
       </p:sp>
       <p:sp>
         <p:nvSpPr>
-          <p:cNvPr id="20" name="TextBox 19"/>
+          <p:cNvPr id="21" name="TextBox 20"/>
           <p:cNvSpPr txBox="1"/>
           <p:nvPr/>
         </p:nvSpPr>
@@ -11564,7 +12588,7 @@
       </p:sp>
       <p:sp>
         <p:nvSpPr>
-          <p:cNvPr id="21" name="TextBox 20"/>
+          <p:cNvPr id="22" name="TextBox 21"/>
           <p:cNvSpPr txBox="1"/>
           <p:nvPr/>
         </p:nvSpPr>
@@ -11592,18 +12616,18 @@
             <a:r>
               <a:rPr sz="1200" b="0">
                 <a:solidFill>
-                  <a:srgbClr val="5B6B7C"/>
-                </a:solidFill>
-                <a:latin typeface="Arial"/>
-              </a:rPr>
-              <a:t>50+TechBridge  ·  Free Lessons  ·  Always free</a:t>
-            </a:r>
-          </a:p>
-        </p:txBody>
-      </p:sp>
-      <p:sp>
-        <p:nvSpPr>
-          <p:cNvPr id="22" name="TextBox 21"/>
+                  <a:srgbClr val="4A5568"/>
+                </a:solidFill>
+                <a:latin typeface="Arial"/>
+              </a:rPr>
+              <a:t>50+ TechBridge  ·  Free Lessons  ·  Always free</a:t>
+            </a:r>
+          </a:p>
+        </p:txBody>
+      </p:sp>
+      <p:sp>
+        <p:nvSpPr>
+          <p:cNvPr id="23" name="TextBox 22"/>
           <p:cNvSpPr txBox="1"/>
           <p:nvPr/>
         </p:nvSpPr>
@@ -11631,7 +12655,7 @@
             <a:r>
               <a:rPr sz="1200" b="0">
                 <a:solidFill>
-                  <a:srgbClr val="5B6B7C"/>
+                  <a:srgbClr val="4A5568"/>
                 </a:solidFill>
                 <a:latin typeface="Arial"/>
               </a:rPr>
@@ -11710,6 +12734,92 @@
         <p:spPr>
           <a:xfrm>
             <a:off x="0" y="0"/>
+            <a:ext cx="4206240" cy="6858000"/>
+          </a:xfrm>
+          <a:prstGeom prst="rect">
+            <a:avLst/>
+          </a:prstGeom>
+          <a:solidFill>
+            <a:srgbClr val="2B315F"/>
+          </a:solidFill>
+          <a:ln>
+            <a:noFill/>
+          </a:ln>
+        </p:spPr>
+        <p:style>
+          <a:lnRef idx="1">
+            <a:schemeClr val="accent1"/>
+          </a:lnRef>
+          <a:fillRef idx="3">
+            <a:schemeClr val="accent1"/>
+          </a:fillRef>
+          <a:effectRef idx="2">
+            <a:schemeClr val="accent1"/>
+          </a:effectRef>
+          <a:fontRef idx="minor">
+            <a:schemeClr val="lt1"/>
+          </a:fontRef>
+        </p:style>
+        <p:txBody>
+          <a:bodyPr rtlCol="0" anchor="ctr"/>
+          <a:lstStyle/>
+          <a:p>
+            <a:pPr algn="ctr"/>
+          </a:p>
+        </p:txBody>
+      </p:sp>
+      <p:sp>
+        <p:nvSpPr>
+          <p:cNvPr id="4" name="Rectangle 3"/>
+          <p:cNvSpPr/>
+          <p:nvPr/>
+        </p:nvSpPr>
+        <p:spPr>
+          <a:xfrm>
+            <a:off x="0" y="6784848"/>
+            <a:ext cx="12191695" cy="73152"/>
+          </a:xfrm>
+          <a:prstGeom prst="rect">
+            <a:avLst/>
+          </a:prstGeom>
+          <a:solidFill>
+            <a:srgbClr val="00A3DC"/>
+          </a:solidFill>
+          <a:ln>
+            <a:noFill/>
+          </a:ln>
+        </p:spPr>
+        <p:style>
+          <a:lnRef idx="1">
+            <a:schemeClr val="accent1"/>
+          </a:lnRef>
+          <a:fillRef idx="3">
+            <a:schemeClr val="accent1"/>
+          </a:fillRef>
+          <a:effectRef idx="2">
+            <a:schemeClr val="accent1"/>
+          </a:effectRef>
+          <a:fontRef idx="minor">
+            <a:schemeClr val="lt1"/>
+          </a:fontRef>
+        </p:style>
+        <p:txBody>
+          <a:bodyPr rtlCol="0" anchor="ctr"/>
+          <a:lstStyle/>
+          <a:p>
+            <a:pPr algn="ctr"/>
+          </a:p>
+        </p:txBody>
+      </p:sp>
+      <p:sp>
+        <p:nvSpPr>
+          <p:cNvPr id="5" name="Rectangle 4"/>
+          <p:cNvSpPr/>
+          <p:nvPr/>
+        </p:nvSpPr>
+        <p:spPr>
+          <a:xfrm>
+            <a:off x="0" y="0"/>
             <a:ext cx="201168" cy="6858000"/>
           </a:xfrm>
           <a:prstGeom prst="rect">
@@ -11746,7 +12856,7 @@
       </p:sp>
       <p:sp>
         <p:nvSpPr>
-          <p:cNvPr id="4" name="TextBox 3"/>
+          <p:cNvPr id="6" name="TextBox 5"/>
           <p:cNvSpPr txBox="1"/>
           <p:nvPr/>
         </p:nvSpPr>
@@ -11817,7 +12927,7 @@
       </p:sp>
       <p:sp>
         <p:nvSpPr>
-          <p:cNvPr id="5" name="TextBox 4"/>
+          <p:cNvPr id="7" name="TextBox 6"/>
           <p:cNvSpPr txBox="1"/>
           <p:nvPr/>
         </p:nvSpPr>
@@ -11861,7 +12971,7 @@
             <a:r>
               <a:rPr sz="1600" b="0">
                 <a:solidFill>
-                  <a:srgbClr val="9AB0C0"/>
+                  <a:srgbClr val="C8DFF0"/>
                 </a:solidFill>
                 <a:latin typeface="Arial"/>
               </a:rPr>
@@ -11872,7 +12982,7 @@
       </p:sp>
       <p:sp>
         <p:nvSpPr>
-          <p:cNvPr id="6" name="TextBox 5"/>
+          <p:cNvPr id="8" name="TextBox 7"/>
           <p:cNvSpPr txBox="1"/>
           <p:nvPr/>
         </p:nvSpPr>
@@ -11900,18 +13010,18 @@
             <a:r>
               <a:rPr sz="1200" b="0">
                 <a:solidFill>
-                  <a:srgbClr val="9AB0C0"/>
-                </a:solidFill>
-                <a:latin typeface="Arial"/>
-              </a:rPr>
-              <a:t>50+TechBridge  ·  Free Lessons  ·  Always free</a:t>
-            </a:r>
-          </a:p>
-        </p:txBody>
-      </p:sp>
-      <p:sp>
-        <p:nvSpPr>
-          <p:cNvPr id="7" name="TextBox 6"/>
+                  <a:srgbClr val="C8DFF0"/>
+                </a:solidFill>
+                <a:latin typeface="Arial"/>
+              </a:rPr>
+              <a:t>50+ TechBridge  ·  Free Lessons  ·  Always free</a:t>
+            </a:r>
+          </a:p>
+        </p:txBody>
+      </p:sp>
+      <p:sp>
+        <p:nvSpPr>
+          <p:cNvPr id="9" name="TextBox 8"/>
           <p:cNvSpPr txBox="1"/>
           <p:nvPr/>
         </p:nvSpPr>
@@ -11939,7 +13049,7 @@
             <a:r>
               <a:rPr sz="1200" b="0">
                 <a:solidFill>
-                  <a:srgbClr val="9AB0C0"/>
+                  <a:srgbClr val="C8DFF0"/>
                 </a:solidFill>
                 <a:latin typeface="Arial"/>
               </a:rPr>
@@ -11981,7 +13091,7 @@
             <a:avLst/>
           </a:prstGeom>
           <a:solidFill>
-            <a:srgbClr val="F7F4EF"/>
+            <a:srgbClr val="FFFFFF"/>
           </a:solidFill>
           <a:ln>
             <a:noFill/>
@@ -12054,7 +13164,50 @@
       </p:sp>
       <p:sp>
         <p:nvSpPr>
-          <p:cNvPr id="4" name="TextBox 3"/>
+          <p:cNvPr id="4" name="Rectangle 3"/>
+          <p:cNvSpPr/>
+          <p:nvPr/>
+        </p:nvSpPr>
+        <p:spPr>
+          <a:xfrm>
+            <a:off x="0" y="6784848"/>
+            <a:ext cx="12191695" cy="73152"/>
+          </a:xfrm>
+          <a:prstGeom prst="rect">
+            <a:avLst/>
+          </a:prstGeom>
+          <a:solidFill>
+            <a:srgbClr val="00A3DC"/>
+          </a:solidFill>
+          <a:ln>
+            <a:noFill/>
+          </a:ln>
+        </p:spPr>
+        <p:style>
+          <a:lnRef idx="1">
+            <a:schemeClr val="accent1"/>
+          </a:lnRef>
+          <a:fillRef idx="3">
+            <a:schemeClr val="accent1"/>
+          </a:fillRef>
+          <a:effectRef idx="2">
+            <a:schemeClr val="accent1"/>
+          </a:effectRef>
+          <a:fontRef idx="minor">
+            <a:schemeClr val="lt1"/>
+          </a:fontRef>
+        </p:style>
+        <p:txBody>
+          <a:bodyPr rtlCol="0" anchor="ctr"/>
+          <a:lstStyle/>
+          <a:p>
+            <a:pPr algn="ctr"/>
+          </a:p>
+        </p:txBody>
+      </p:sp>
+      <p:sp>
+        <p:nvSpPr>
+          <p:cNvPr id="5" name="TextBox 4"/>
           <p:cNvSpPr txBox="1"/>
           <p:nvPr/>
         </p:nvSpPr>
@@ -12093,7 +13246,7 @@
       </p:sp>
       <p:sp>
         <p:nvSpPr>
-          <p:cNvPr id="5" name="TextBox 4"/>
+          <p:cNvPr id="6" name="TextBox 5"/>
           <p:cNvSpPr txBox="1"/>
           <p:nvPr/>
         </p:nvSpPr>
@@ -12121,7 +13274,7 @@
             <a:r>
               <a:rPr sz="2200" b="0">
                 <a:solidFill>
-                  <a:srgbClr val="3D4A5C"/>
+                  <a:srgbClr val="4A5568"/>
                 </a:solidFill>
                 <a:latin typeface="Arial"/>
               </a:rPr>
@@ -12137,7 +13290,7 @@
             <a:r>
               <a:rPr sz="2200" b="0">
                 <a:solidFill>
-                  <a:srgbClr val="3D4A5C"/>
+                  <a:srgbClr val="4A5568"/>
                 </a:solidFill>
                 <a:latin typeface="Arial"/>
               </a:rPr>
@@ -12153,7 +13306,7 @@
             <a:r>
               <a:rPr sz="2200" b="0">
                 <a:solidFill>
-                  <a:srgbClr val="3D4A5C"/>
+                  <a:srgbClr val="4A5568"/>
                 </a:solidFill>
                 <a:latin typeface="Arial"/>
               </a:rPr>
@@ -12169,7 +13322,7 @@
             <a:r>
               <a:rPr sz="2200" b="0">
                 <a:solidFill>
-                  <a:srgbClr val="3D4A5C"/>
+                  <a:srgbClr val="4A5568"/>
                 </a:solidFill>
                 <a:latin typeface="Arial"/>
               </a:rPr>
@@ -12185,7 +13338,7 @@
             <a:r>
               <a:rPr sz="2200" b="0">
                 <a:solidFill>
-                  <a:srgbClr val="3D4A5C"/>
+                  <a:srgbClr val="4A5568"/>
                 </a:solidFill>
                 <a:latin typeface="Arial"/>
               </a:rPr>
@@ -12196,7 +13349,7 @@
       </p:sp>
       <p:sp>
         <p:nvSpPr>
-          <p:cNvPr id="6" name="TextBox 5"/>
+          <p:cNvPr id="7" name="TextBox 6"/>
           <p:cNvSpPr txBox="1"/>
           <p:nvPr/>
         </p:nvSpPr>
@@ -12224,18 +13377,18 @@
             <a:r>
               <a:rPr sz="1200" b="0">
                 <a:solidFill>
-                  <a:srgbClr val="5B6B7C"/>
-                </a:solidFill>
-                <a:latin typeface="Arial"/>
-              </a:rPr>
-              <a:t>50+TechBridge  ·  Free Lessons  ·  Always free</a:t>
-            </a:r>
-          </a:p>
-        </p:txBody>
-      </p:sp>
-      <p:sp>
-        <p:nvSpPr>
-          <p:cNvPr id="7" name="TextBox 6"/>
+                  <a:srgbClr val="4A5568"/>
+                </a:solidFill>
+                <a:latin typeface="Arial"/>
+              </a:rPr>
+              <a:t>50+ TechBridge  ·  Free Lessons  ·  Always free</a:t>
+            </a:r>
+          </a:p>
+        </p:txBody>
+      </p:sp>
+      <p:sp>
+        <p:nvSpPr>
+          <p:cNvPr id="8" name="TextBox 7"/>
           <p:cNvSpPr txBox="1"/>
           <p:nvPr/>
         </p:nvSpPr>
@@ -12263,7 +13416,7 @@
             <a:r>
               <a:rPr sz="1200" b="0">
                 <a:solidFill>
-                  <a:srgbClr val="5B6B7C"/>
+                  <a:srgbClr val="4A5568"/>
                 </a:solidFill>
                 <a:latin typeface="Arial"/>
               </a:rPr>
@@ -12342,6 +13495,92 @@
         <p:spPr>
           <a:xfrm>
             <a:off x="0" y="0"/>
+            <a:ext cx="4206240" cy="6858000"/>
+          </a:xfrm>
+          <a:prstGeom prst="rect">
+            <a:avLst/>
+          </a:prstGeom>
+          <a:solidFill>
+            <a:srgbClr val="2B315F"/>
+          </a:solidFill>
+          <a:ln>
+            <a:noFill/>
+          </a:ln>
+        </p:spPr>
+        <p:style>
+          <a:lnRef idx="1">
+            <a:schemeClr val="accent1"/>
+          </a:lnRef>
+          <a:fillRef idx="3">
+            <a:schemeClr val="accent1"/>
+          </a:fillRef>
+          <a:effectRef idx="2">
+            <a:schemeClr val="accent1"/>
+          </a:effectRef>
+          <a:fontRef idx="minor">
+            <a:schemeClr val="lt1"/>
+          </a:fontRef>
+        </p:style>
+        <p:txBody>
+          <a:bodyPr rtlCol="0" anchor="ctr"/>
+          <a:lstStyle/>
+          <a:p>
+            <a:pPr algn="ctr"/>
+          </a:p>
+        </p:txBody>
+      </p:sp>
+      <p:sp>
+        <p:nvSpPr>
+          <p:cNvPr id="4" name="Rectangle 3"/>
+          <p:cNvSpPr/>
+          <p:nvPr/>
+        </p:nvSpPr>
+        <p:spPr>
+          <a:xfrm>
+            <a:off x="0" y="6784848"/>
+            <a:ext cx="12191695" cy="73152"/>
+          </a:xfrm>
+          <a:prstGeom prst="rect">
+            <a:avLst/>
+          </a:prstGeom>
+          <a:solidFill>
+            <a:srgbClr val="00A3DC"/>
+          </a:solidFill>
+          <a:ln>
+            <a:noFill/>
+          </a:ln>
+        </p:spPr>
+        <p:style>
+          <a:lnRef idx="1">
+            <a:schemeClr val="accent1"/>
+          </a:lnRef>
+          <a:fillRef idx="3">
+            <a:schemeClr val="accent1"/>
+          </a:fillRef>
+          <a:effectRef idx="2">
+            <a:schemeClr val="accent1"/>
+          </a:effectRef>
+          <a:fontRef idx="minor">
+            <a:schemeClr val="lt1"/>
+          </a:fontRef>
+        </p:style>
+        <p:txBody>
+          <a:bodyPr rtlCol="0" anchor="ctr"/>
+          <a:lstStyle/>
+          <a:p>
+            <a:pPr algn="ctr"/>
+          </a:p>
+        </p:txBody>
+      </p:sp>
+      <p:sp>
+        <p:nvSpPr>
+          <p:cNvPr id="5" name="Rectangle 4"/>
+          <p:cNvSpPr/>
+          <p:nvPr/>
+        </p:nvSpPr>
+        <p:spPr>
+          <a:xfrm>
+            <a:off x="0" y="0"/>
             <a:ext cx="12191695" cy="109728"/>
           </a:xfrm>
           <a:prstGeom prst="rect">
@@ -12378,7 +13617,7 @@
       </p:sp>
       <p:sp>
         <p:nvSpPr>
-          <p:cNvPr id="4" name="TextBox 3"/>
+          <p:cNvPr id="6" name="TextBox 5"/>
           <p:cNvSpPr txBox="1"/>
           <p:nvPr/>
         </p:nvSpPr>
@@ -12422,7 +13661,7 @@
             <a:r>
               <a:rPr sz="1600" b="0">
                 <a:solidFill>
-                  <a:srgbClr val="9AB0C0"/>
+                  <a:srgbClr val="C8DFF0"/>
                 </a:solidFill>
                 <a:latin typeface="Arial"/>
               </a:rPr>
@@ -12433,7 +13672,7 @@
       </p:sp>
       <p:sp>
         <p:nvSpPr>
-          <p:cNvPr id="5" name="Rectangle 4"/>
+          <p:cNvPr id="7" name="Rectangle 6"/>
           <p:cNvSpPr/>
           <p:nvPr/>
         </p:nvSpPr>
@@ -12476,7 +13715,7 @@
       </p:sp>
       <p:sp>
         <p:nvSpPr>
-          <p:cNvPr id="6" name="TextBox 5"/>
+          <p:cNvPr id="8" name="TextBox 7"/>
           <p:cNvSpPr txBox="1"/>
           <p:nvPr/>
         </p:nvSpPr>
@@ -12515,7 +13754,7 @@
       </p:sp>
       <p:sp>
         <p:nvSpPr>
-          <p:cNvPr id="7" name="TextBox 6"/>
+          <p:cNvPr id="9" name="TextBox 8"/>
           <p:cNvSpPr txBox="1"/>
           <p:nvPr/>
         </p:nvSpPr>
@@ -12554,7 +13793,7 @@
       </p:sp>
       <p:sp>
         <p:nvSpPr>
-          <p:cNvPr id="8" name="Rectangle 7"/>
+          <p:cNvPr id="10" name="Rectangle 9"/>
           <p:cNvSpPr/>
           <p:nvPr/>
         </p:nvSpPr>
@@ -12597,7 +13836,7 @@
       </p:sp>
       <p:sp>
         <p:nvSpPr>
-          <p:cNvPr id="9" name="TextBox 8"/>
+          <p:cNvPr id="11" name="TextBox 10"/>
           <p:cNvSpPr txBox="1"/>
           <p:nvPr/>
         </p:nvSpPr>
@@ -12636,7 +13875,7 @@
       </p:sp>
       <p:sp>
         <p:nvSpPr>
-          <p:cNvPr id="10" name="TextBox 9"/>
+          <p:cNvPr id="12" name="TextBox 11"/>
           <p:cNvSpPr txBox="1"/>
           <p:nvPr/>
         </p:nvSpPr>
@@ -12675,7 +13914,7 @@
       </p:sp>
       <p:sp>
         <p:nvSpPr>
-          <p:cNvPr id="11" name="Rectangle 10"/>
+          <p:cNvPr id="13" name="Rectangle 12"/>
           <p:cNvSpPr/>
           <p:nvPr/>
         </p:nvSpPr>
@@ -12718,7 +13957,7 @@
       </p:sp>
       <p:sp>
         <p:nvSpPr>
-          <p:cNvPr id="12" name="TextBox 11"/>
+          <p:cNvPr id="14" name="TextBox 13"/>
           <p:cNvSpPr txBox="1"/>
           <p:nvPr/>
         </p:nvSpPr>
@@ -12757,7 +13996,7 @@
       </p:sp>
       <p:sp>
         <p:nvSpPr>
-          <p:cNvPr id="13" name="TextBox 12"/>
+          <p:cNvPr id="15" name="TextBox 14"/>
           <p:cNvSpPr txBox="1"/>
           <p:nvPr/>
         </p:nvSpPr>
@@ -12796,7 +14035,7 @@
       </p:sp>
       <p:sp>
         <p:nvSpPr>
-          <p:cNvPr id="14" name="TextBox 13"/>
+          <p:cNvPr id="16" name="TextBox 15"/>
           <p:cNvSpPr txBox="1"/>
           <p:nvPr/>
         </p:nvSpPr>
@@ -12824,18 +14063,18 @@
             <a:r>
               <a:rPr sz="1200" b="0">
                 <a:solidFill>
-                  <a:srgbClr val="9AB0C0"/>
-                </a:solidFill>
-                <a:latin typeface="Arial"/>
-              </a:rPr>
-              <a:t>50+TechBridge  ·  Free Lessons  ·  Always free</a:t>
-            </a:r>
-          </a:p>
-        </p:txBody>
-      </p:sp>
-      <p:sp>
-        <p:nvSpPr>
-          <p:cNvPr id="15" name="TextBox 14"/>
+                  <a:srgbClr val="C8DFF0"/>
+                </a:solidFill>
+                <a:latin typeface="Arial"/>
+              </a:rPr>
+              <a:t>50+ TechBridge  ·  Free Lessons  ·  Always free</a:t>
+            </a:r>
+          </a:p>
+        </p:txBody>
+      </p:sp>
+      <p:sp>
+        <p:nvSpPr>
+          <p:cNvPr id="17" name="TextBox 16"/>
           <p:cNvSpPr txBox="1"/>
           <p:nvPr/>
         </p:nvSpPr>
@@ -12863,7 +14102,7 @@
             <a:r>
               <a:rPr sz="1200" b="0">
                 <a:solidFill>
-                  <a:srgbClr val="9AB0C0"/>
+                  <a:srgbClr val="C8DFF0"/>
                 </a:solidFill>
                 <a:latin typeface="Arial"/>
               </a:rPr>
@@ -12942,6 +14181,92 @@
         <p:spPr>
           <a:xfrm>
             <a:off x="0" y="0"/>
+            <a:ext cx="4206240" cy="6858000"/>
+          </a:xfrm>
+          <a:prstGeom prst="rect">
+            <a:avLst/>
+          </a:prstGeom>
+          <a:solidFill>
+            <a:srgbClr val="2B315F"/>
+          </a:solidFill>
+          <a:ln>
+            <a:noFill/>
+          </a:ln>
+        </p:spPr>
+        <p:style>
+          <a:lnRef idx="1">
+            <a:schemeClr val="accent1"/>
+          </a:lnRef>
+          <a:fillRef idx="3">
+            <a:schemeClr val="accent1"/>
+          </a:fillRef>
+          <a:effectRef idx="2">
+            <a:schemeClr val="accent1"/>
+          </a:effectRef>
+          <a:fontRef idx="minor">
+            <a:schemeClr val="lt1"/>
+          </a:fontRef>
+        </p:style>
+        <p:txBody>
+          <a:bodyPr rtlCol="0" anchor="ctr"/>
+          <a:lstStyle/>
+          <a:p>
+            <a:pPr algn="ctr"/>
+          </a:p>
+        </p:txBody>
+      </p:sp>
+      <p:sp>
+        <p:nvSpPr>
+          <p:cNvPr id="4" name="Rectangle 3"/>
+          <p:cNvSpPr/>
+          <p:nvPr/>
+        </p:nvSpPr>
+        <p:spPr>
+          <a:xfrm>
+            <a:off x="0" y="6784848"/>
+            <a:ext cx="12191695" cy="73152"/>
+          </a:xfrm>
+          <a:prstGeom prst="rect">
+            <a:avLst/>
+          </a:prstGeom>
+          <a:solidFill>
+            <a:srgbClr val="00A3DC"/>
+          </a:solidFill>
+          <a:ln>
+            <a:noFill/>
+          </a:ln>
+        </p:spPr>
+        <p:style>
+          <a:lnRef idx="1">
+            <a:schemeClr val="accent1"/>
+          </a:lnRef>
+          <a:fillRef idx="3">
+            <a:schemeClr val="accent1"/>
+          </a:fillRef>
+          <a:effectRef idx="2">
+            <a:schemeClr val="accent1"/>
+          </a:effectRef>
+          <a:fontRef idx="minor">
+            <a:schemeClr val="lt1"/>
+          </a:fontRef>
+        </p:style>
+        <p:txBody>
+          <a:bodyPr rtlCol="0" anchor="ctr"/>
+          <a:lstStyle/>
+          <a:p>
+            <a:pPr algn="ctr"/>
+          </a:p>
+        </p:txBody>
+      </p:sp>
+      <p:sp>
+        <p:nvSpPr>
+          <p:cNvPr id="5" name="Rectangle 4"/>
+          <p:cNvSpPr/>
+          <p:nvPr/>
+        </p:nvSpPr>
+        <p:spPr>
+          <a:xfrm>
+            <a:off x="0" y="0"/>
             <a:ext cx="201168" cy="6858000"/>
           </a:xfrm>
           <a:prstGeom prst="rect">
@@ -12978,7 +14303,7 @@
       </p:sp>
       <p:sp>
         <p:nvSpPr>
-          <p:cNvPr id="4" name="TextBox 3"/>
+          <p:cNvPr id="6" name="TextBox 5"/>
           <p:cNvSpPr txBox="1"/>
           <p:nvPr/>
         </p:nvSpPr>
@@ -13049,7 +14374,7 @@
       </p:sp>
       <p:sp>
         <p:nvSpPr>
-          <p:cNvPr id="5" name="TextBox 4"/>
+          <p:cNvPr id="7" name="TextBox 6"/>
           <p:cNvSpPr txBox="1"/>
           <p:nvPr/>
         </p:nvSpPr>
@@ -13077,18 +14402,18 @@
             <a:r>
               <a:rPr sz="1200" b="0">
                 <a:solidFill>
-                  <a:srgbClr val="9AB0C0"/>
-                </a:solidFill>
-                <a:latin typeface="Arial"/>
-              </a:rPr>
-              <a:t>50+TechBridge  ·  Free Lessons  ·  Always free</a:t>
-            </a:r>
-          </a:p>
-        </p:txBody>
-      </p:sp>
-      <p:sp>
-        <p:nvSpPr>
-          <p:cNvPr id="6" name="TextBox 5"/>
+                  <a:srgbClr val="C8DFF0"/>
+                </a:solidFill>
+                <a:latin typeface="Arial"/>
+              </a:rPr>
+              <a:t>50+ TechBridge  ·  Free Lessons  ·  Always free</a:t>
+            </a:r>
+          </a:p>
+        </p:txBody>
+      </p:sp>
+      <p:sp>
+        <p:nvSpPr>
+          <p:cNvPr id="8" name="TextBox 7"/>
           <p:cNvSpPr txBox="1"/>
           <p:nvPr/>
         </p:nvSpPr>
@@ -13116,7 +14441,7 @@
             <a:r>
               <a:rPr sz="1200" b="0">
                 <a:solidFill>
-                  <a:srgbClr val="9AB0C0"/>
+                  <a:srgbClr val="C8DFF0"/>
                 </a:solidFill>
                 <a:latin typeface="Arial"/>
               </a:rPr>
@@ -13158,7 +14483,7 @@
             <a:avLst/>
           </a:prstGeom>
           <a:solidFill>
-            <a:srgbClr val="F7F4EF"/>
+            <a:srgbClr val="FFFFFF"/>
           </a:solidFill>
           <a:ln>
             <a:noFill/>
@@ -13231,7 +14556,50 @@
       </p:sp>
       <p:sp>
         <p:nvSpPr>
-          <p:cNvPr id="4" name="TextBox 3"/>
+          <p:cNvPr id="4" name="Rectangle 3"/>
+          <p:cNvSpPr/>
+          <p:nvPr/>
+        </p:nvSpPr>
+        <p:spPr>
+          <a:xfrm>
+            <a:off x="0" y="6784848"/>
+            <a:ext cx="12191695" cy="73152"/>
+          </a:xfrm>
+          <a:prstGeom prst="rect">
+            <a:avLst/>
+          </a:prstGeom>
+          <a:solidFill>
+            <a:srgbClr val="00A3DC"/>
+          </a:solidFill>
+          <a:ln>
+            <a:noFill/>
+          </a:ln>
+        </p:spPr>
+        <p:style>
+          <a:lnRef idx="1">
+            <a:schemeClr val="accent1"/>
+          </a:lnRef>
+          <a:fillRef idx="3">
+            <a:schemeClr val="accent1"/>
+          </a:fillRef>
+          <a:effectRef idx="2">
+            <a:schemeClr val="accent1"/>
+          </a:effectRef>
+          <a:fontRef idx="minor">
+            <a:schemeClr val="lt1"/>
+          </a:fontRef>
+        </p:style>
+        <p:txBody>
+          <a:bodyPr rtlCol="0" anchor="ctr"/>
+          <a:lstStyle/>
+          <a:p>
+            <a:pPr algn="ctr"/>
+          </a:p>
+        </p:txBody>
+      </p:sp>
+      <p:sp>
+        <p:nvSpPr>
+          <p:cNvPr id="5" name="TextBox 4"/>
           <p:cNvSpPr txBox="1"/>
           <p:nvPr/>
         </p:nvSpPr>
@@ -13270,7 +14638,7 @@
       </p:sp>
       <p:sp>
         <p:nvSpPr>
-          <p:cNvPr id="5" name="TextBox 4"/>
+          <p:cNvPr id="6" name="TextBox 5"/>
           <p:cNvSpPr txBox="1"/>
           <p:nvPr/>
         </p:nvSpPr>
@@ -13314,7 +14682,7 @@
             <a:r>
               <a:rPr sz="3200" b="0">
                 <a:solidFill>
-                  <a:srgbClr val="3D4A5C"/>
+                  <a:srgbClr val="4A5568"/>
                 </a:solidFill>
                 <a:latin typeface="Arial"/>
               </a:rPr>
@@ -13325,7 +14693,7 @@
       </p:sp>
       <p:sp>
         <p:nvSpPr>
-          <p:cNvPr id="6" name="TextBox 5"/>
+          <p:cNvPr id="7" name="TextBox 6"/>
           <p:cNvSpPr txBox="1"/>
           <p:nvPr/>
         </p:nvSpPr>
@@ -13353,18 +14721,18 @@
             <a:r>
               <a:rPr sz="1200" b="0">
                 <a:solidFill>
-                  <a:srgbClr val="5B6B7C"/>
-                </a:solidFill>
-                <a:latin typeface="Arial"/>
-              </a:rPr>
-              <a:t>50+TechBridge  ·  Free Lessons  ·  Always free</a:t>
-            </a:r>
-          </a:p>
-        </p:txBody>
-      </p:sp>
-      <p:sp>
-        <p:nvSpPr>
-          <p:cNvPr id="7" name="TextBox 6"/>
+                  <a:srgbClr val="4A5568"/>
+                </a:solidFill>
+                <a:latin typeface="Arial"/>
+              </a:rPr>
+              <a:t>50+ TechBridge  ·  Free Lessons  ·  Always free</a:t>
+            </a:r>
+          </a:p>
+        </p:txBody>
+      </p:sp>
+      <p:sp>
+        <p:nvSpPr>
+          <p:cNvPr id="8" name="TextBox 7"/>
           <p:cNvSpPr txBox="1"/>
           <p:nvPr/>
         </p:nvSpPr>
@@ -13392,7 +14760,7 @@
             <a:r>
               <a:rPr sz="1200" b="0">
                 <a:solidFill>
-                  <a:srgbClr val="5B6B7C"/>
+                  <a:srgbClr val="4A5568"/>
                 </a:solidFill>
                 <a:latin typeface="Arial"/>
               </a:rPr>
@@ -13434,7 +14802,7 @@
             <a:avLst/>
           </a:prstGeom>
           <a:solidFill>
-            <a:srgbClr val="F7F4EF"/>
+            <a:srgbClr val="FFFFFF"/>
           </a:solidFill>
           <a:ln>
             <a:noFill/>
@@ -13507,7 +14875,50 @@
       </p:sp>
       <p:sp>
         <p:nvSpPr>
-          <p:cNvPr id="4" name="TextBox 3"/>
+          <p:cNvPr id="4" name="Rectangle 3"/>
+          <p:cNvSpPr/>
+          <p:nvPr/>
+        </p:nvSpPr>
+        <p:spPr>
+          <a:xfrm>
+            <a:off x="0" y="6784848"/>
+            <a:ext cx="12191695" cy="73152"/>
+          </a:xfrm>
+          <a:prstGeom prst="rect">
+            <a:avLst/>
+          </a:prstGeom>
+          <a:solidFill>
+            <a:srgbClr val="00A3DC"/>
+          </a:solidFill>
+          <a:ln>
+            <a:noFill/>
+          </a:ln>
+        </p:spPr>
+        <p:style>
+          <a:lnRef idx="1">
+            <a:schemeClr val="accent1"/>
+          </a:lnRef>
+          <a:fillRef idx="3">
+            <a:schemeClr val="accent1"/>
+          </a:fillRef>
+          <a:effectRef idx="2">
+            <a:schemeClr val="accent1"/>
+          </a:effectRef>
+          <a:fontRef idx="minor">
+            <a:schemeClr val="lt1"/>
+          </a:fontRef>
+        </p:style>
+        <p:txBody>
+          <a:bodyPr rtlCol="0" anchor="ctr"/>
+          <a:lstStyle/>
+          <a:p>
+            <a:pPr algn="ctr"/>
+          </a:p>
+        </p:txBody>
+      </p:sp>
+      <p:sp>
+        <p:nvSpPr>
+          <p:cNvPr id="5" name="TextBox 4"/>
           <p:cNvSpPr txBox="1"/>
           <p:nvPr/>
         </p:nvSpPr>
@@ -13551,7 +14962,7 @@
             <a:r>
               <a:rPr sz="1800" b="0">
                 <a:solidFill>
-                  <a:srgbClr val="3D4A5C"/>
+                  <a:srgbClr val="4A5568"/>
                 </a:solidFill>
                 <a:latin typeface="Arial"/>
               </a:rPr>
@@ -13562,7 +14973,7 @@
       </p:sp>
       <p:sp>
         <p:nvSpPr>
-          <p:cNvPr id="5" name="TextBox 4"/>
+          <p:cNvPr id="6" name="TextBox 5"/>
           <p:cNvSpPr txBox="1"/>
           <p:nvPr/>
         </p:nvSpPr>
@@ -13590,7 +15001,7 @@
             <a:r>
               <a:rPr sz="2000" b="0">
                 <a:solidFill>
-                  <a:srgbClr val="3D4A5C"/>
+                  <a:srgbClr val="4A5568"/>
                 </a:solidFill>
                 <a:latin typeface="Arial"/>
               </a:rPr>
@@ -13606,7 +15017,7 @@
             <a:r>
               <a:rPr sz="2000" b="0">
                 <a:solidFill>
-                  <a:srgbClr val="3D4A5C"/>
+                  <a:srgbClr val="4A5568"/>
                 </a:solidFill>
                 <a:latin typeface="Arial"/>
               </a:rPr>
@@ -13622,7 +15033,7 @@
             <a:r>
               <a:rPr sz="2000" b="0">
                 <a:solidFill>
-                  <a:srgbClr val="3D4A5C"/>
+                  <a:srgbClr val="4A5568"/>
                 </a:solidFill>
                 <a:latin typeface="Arial"/>
               </a:rPr>
@@ -13638,7 +15049,7 @@
             <a:r>
               <a:rPr sz="2000" b="0">
                 <a:solidFill>
-                  <a:srgbClr val="3D4A5C"/>
+                  <a:srgbClr val="4A5568"/>
                 </a:solidFill>
                 <a:latin typeface="Arial"/>
               </a:rPr>
@@ -13649,7 +15060,7 @@
       </p:sp>
       <p:sp>
         <p:nvSpPr>
-          <p:cNvPr id="6" name="TextBox 5"/>
+          <p:cNvPr id="7" name="TextBox 6"/>
           <p:cNvSpPr txBox="1"/>
           <p:nvPr/>
         </p:nvSpPr>
@@ -13688,7 +15099,7 @@
       </p:sp>
       <p:sp>
         <p:nvSpPr>
-          <p:cNvPr id="7" name="TextBox 6"/>
+          <p:cNvPr id="8" name="TextBox 7"/>
           <p:cNvSpPr txBox="1"/>
           <p:nvPr/>
         </p:nvSpPr>
@@ -13716,18 +15127,18 @@
             <a:r>
               <a:rPr sz="1200" b="0">
                 <a:solidFill>
-                  <a:srgbClr val="5B6B7C"/>
-                </a:solidFill>
-                <a:latin typeface="Arial"/>
-              </a:rPr>
-              <a:t>50+TechBridge  ·  Free Lessons  ·  Always free</a:t>
-            </a:r>
-          </a:p>
-        </p:txBody>
-      </p:sp>
-      <p:sp>
-        <p:nvSpPr>
-          <p:cNvPr id="8" name="TextBox 7"/>
+                  <a:srgbClr val="4A5568"/>
+                </a:solidFill>
+                <a:latin typeface="Arial"/>
+              </a:rPr>
+              <a:t>50+ TechBridge  ·  Free Lessons  ·  Always free</a:t>
+            </a:r>
+          </a:p>
+        </p:txBody>
+      </p:sp>
+      <p:sp>
+        <p:nvSpPr>
+          <p:cNvPr id="9" name="TextBox 8"/>
           <p:cNvSpPr txBox="1"/>
           <p:nvPr/>
         </p:nvSpPr>
@@ -13755,7 +15166,7 @@
             <a:r>
               <a:rPr sz="1200" b="0">
                 <a:solidFill>
-                  <a:srgbClr val="5B6B7C"/>
+                  <a:srgbClr val="4A5568"/>
                 </a:solidFill>
                 <a:latin typeface="Arial"/>
               </a:rPr>
@@ -13834,7 +15245,50 @@
         <p:spPr>
           <a:xfrm>
             <a:off x="0" y="0"/>
-            <a:ext cx="201168" cy="6858000"/>
+            <a:ext cx="4206240" cy="6858000"/>
+          </a:xfrm>
+          <a:prstGeom prst="rect">
+            <a:avLst/>
+          </a:prstGeom>
+          <a:solidFill>
+            <a:srgbClr val="2B315F"/>
+          </a:solidFill>
+          <a:ln>
+            <a:noFill/>
+          </a:ln>
+        </p:spPr>
+        <p:style>
+          <a:lnRef idx="1">
+            <a:schemeClr val="accent1"/>
+          </a:lnRef>
+          <a:fillRef idx="3">
+            <a:schemeClr val="accent1"/>
+          </a:fillRef>
+          <a:effectRef idx="2">
+            <a:schemeClr val="accent1"/>
+          </a:effectRef>
+          <a:fontRef idx="minor">
+            <a:schemeClr val="lt1"/>
+          </a:fontRef>
+        </p:style>
+        <p:txBody>
+          <a:bodyPr rtlCol="0" anchor="ctr"/>
+          <a:lstStyle/>
+          <a:p>
+            <a:pPr algn="ctr"/>
+          </a:p>
+        </p:txBody>
+      </p:sp>
+      <p:sp>
+        <p:nvSpPr>
+          <p:cNvPr id="4" name="Rectangle 3"/>
+          <p:cNvSpPr/>
+          <p:nvPr/>
+        </p:nvSpPr>
+        <p:spPr>
+          <a:xfrm>
+            <a:off x="0" y="6784848"/>
+            <a:ext cx="12191695" cy="73152"/>
           </a:xfrm>
           <a:prstGeom prst="rect">
             <a:avLst/>
@@ -13870,7 +15324,50 @@
       </p:sp>
       <p:sp>
         <p:nvSpPr>
-          <p:cNvPr id="4" name="TextBox 3"/>
+          <p:cNvPr id="5" name="Rectangle 4"/>
+          <p:cNvSpPr/>
+          <p:nvPr/>
+        </p:nvSpPr>
+        <p:spPr>
+          <a:xfrm>
+            <a:off x="0" y="0"/>
+            <a:ext cx="201168" cy="6858000"/>
+          </a:xfrm>
+          <a:prstGeom prst="rect">
+            <a:avLst/>
+          </a:prstGeom>
+          <a:solidFill>
+            <a:srgbClr val="00A3DC"/>
+          </a:solidFill>
+          <a:ln>
+            <a:noFill/>
+          </a:ln>
+        </p:spPr>
+        <p:style>
+          <a:lnRef idx="1">
+            <a:schemeClr val="accent1"/>
+          </a:lnRef>
+          <a:fillRef idx="3">
+            <a:schemeClr val="accent1"/>
+          </a:fillRef>
+          <a:effectRef idx="2">
+            <a:schemeClr val="accent1"/>
+          </a:effectRef>
+          <a:fontRef idx="minor">
+            <a:schemeClr val="lt1"/>
+          </a:fontRef>
+        </p:style>
+        <p:txBody>
+          <a:bodyPr rtlCol="0" anchor="ctr"/>
+          <a:lstStyle/>
+          <a:p>
+            <a:pPr algn="ctr"/>
+          </a:p>
+        </p:txBody>
+      </p:sp>
+      <p:sp>
+        <p:nvSpPr>
+          <p:cNvPr id="6" name="TextBox 5"/>
           <p:cNvSpPr txBox="1"/>
           <p:nvPr/>
         </p:nvSpPr>
@@ -13941,7 +15438,7 @@
       </p:sp>
       <p:sp>
         <p:nvSpPr>
-          <p:cNvPr id="5" name="TextBox 4"/>
+          <p:cNvPr id="7" name="TextBox 6"/>
           <p:cNvSpPr txBox="1"/>
           <p:nvPr/>
         </p:nvSpPr>
@@ -13969,18 +15466,18 @@
             <a:r>
               <a:rPr sz="1200" b="0">
                 <a:solidFill>
-                  <a:srgbClr val="9AB0C0"/>
-                </a:solidFill>
-                <a:latin typeface="Arial"/>
-              </a:rPr>
-              <a:t>50+TechBridge  ·  Free Lessons  ·  Always free</a:t>
-            </a:r>
-          </a:p>
-        </p:txBody>
-      </p:sp>
-      <p:sp>
-        <p:nvSpPr>
-          <p:cNvPr id="6" name="TextBox 5"/>
+                  <a:srgbClr val="C8DFF0"/>
+                </a:solidFill>
+                <a:latin typeface="Arial"/>
+              </a:rPr>
+              <a:t>50+ TechBridge  ·  Free Lessons  ·  Always free</a:t>
+            </a:r>
+          </a:p>
+        </p:txBody>
+      </p:sp>
+      <p:sp>
+        <p:nvSpPr>
+          <p:cNvPr id="8" name="TextBox 7"/>
           <p:cNvSpPr txBox="1"/>
           <p:nvPr/>
         </p:nvSpPr>
@@ -14008,7 +15505,7 @@
             <a:r>
               <a:rPr sz="1200" b="0">
                 <a:solidFill>
-                  <a:srgbClr val="9AB0C0"/>
+                  <a:srgbClr val="C8DFF0"/>
                 </a:solidFill>
                 <a:latin typeface="Arial"/>
               </a:rPr>
@@ -14050,7 +15547,7 @@
             <a:avLst/>
           </a:prstGeom>
           <a:solidFill>
-            <a:srgbClr val="F7F4EF"/>
+            <a:srgbClr val="FFFFFF"/>
           </a:solidFill>
           <a:ln>
             <a:noFill/>
@@ -14123,75 +15620,20 @@
       </p:sp>
       <p:sp>
         <p:nvSpPr>
-          <p:cNvPr id="4" name="TextBox 3"/>
-          <p:cNvSpPr txBox="1"/>
-          <p:nvPr/>
-        </p:nvSpPr>
-        <p:spPr>
-          <a:xfrm>
-            <a:off x="548640" y="320040"/>
-            <a:ext cx="10972800" cy="822960"/>
-          </a:xfrm>
-          <a:prstGeom prst="rect">
-            <a:avLst/>
-          </a:prstGeom>
-          <a:noFill/>
-        </p:spPr>
-        <p:txBody>
-          <a:bodyPr wrap="square">
-            <a:spAutoFit/>
-          </a:bodyPr>
-          <a:lstStyle/>
-          <a:p>
-            <a:pPr algn="l">
-              <a:spcAft>
-                <a:spcPts val="800"/>
-              </a:spcAft>
-            </a:pPr>
-            <a:r>
-              <a:rPr sz="3400" b="1">
-                <a:solidFill>
-                  <a:srgbClr val="083655"/>
-                </a:solidFill>
-                <a:latin typeface="Arial"/>
-              </a:rPr>
-              <a:t>Before anyone types</a:t>
-            </a:r>
-          </a:p>
-          <a:p>
-            <a:pPr algn="l">
-              <a:spcAft>
-                <a:spcPts val="800"/>
-              </a:spcAft>
-            </a:pPr>
-            <a:r>
-              <a:rPr sz="1800" b="0">
-                <a:solidFill>
-                  <a:srgbClr val="3D4A5C"/>
-                </a:solidFill>
-                <a:latin typeface="Arial"/>
-              </a:rPr>
-              <a:t>Put this on screen. Do not skip it.</a:t>
-            </a:r>
-          </a:p>
-        </p:txBody>
-      </p:sp>
-      <p:sp>
-        <p:nvSpPr>
-          <p:cNvPr id="5" name="Rectangle 4"/>
+          <p:cNvPr id="4" name="Rectangle 3"/>
           <p:cNvSpPr/>
           <p:nvPr/>
         </p:nvSpPr>
         <p:spPr>
           <a:xfrm>
-            <a:off x="548640" y="1371600"/>
-            <a:ext cx="11064240" cy="960120"/>
+            <a:off x="0" y="6784848"/>
+            <a:ext cx="12191695" cy="73152"/>
           </a:xfrm>
           <a:prstGeom prst="rect">
             <a:avLst/>
           </a:prstGeom>
           <a:solidFill>
-            <a:srgbClr val="FFFFFF"/>
+            <a:srgbClr val="00A3DC"/>
           </a:solidFill>
           <a:ln>
             <a:noFill/>
@@ -14221,7 +15663,105 @@
       </p:sp>
       <p:sp>
         <p:nvSpPr>
+          <p:cNvPr id="5" name="TextBox 4"/>
+          <p:cNvSpPr txBox="1"/>
+          <p:nvPr/>
+        </p:nvSpPr>
+        <p:spPr>
+          <a:xfrm>
+            <a:off x="548640" y="320040"/>
+            <a:ext cx="10972800" cy="822960"/>
+          </a:xfrm>
+          <a:prstGeom prst="rect">
+            <a:avLst/>
+          </a:prstGeom>
+          <a:noFill/>
+        </p:spPr>
+        <p:txBody>
+          <a:bodyPr wrap="square">
+            <a:spAutoFit/>
+          </a:bodyPr>
+          <a:lstStyle/>
+          <a:p>
+            <a:pPr algn="l">
+              <a:spcAft>
+                <a:spcPts val="800"/>
+              </a:spcAft>
+            </a:pPr>
+            <a:r>
+              <a:rPr sz="3400" b="1">
+                <a:solidFill>
+                  <a:srgbClr val="083655"/>
+                </a:solidFill>
+                <a:latin typeface="Arial"/>
+              </a:rPr>
+              <a:t>Before anyone types</a:t>
+            </a:r>
+          </a:p>
+          <a:p>
+            <a:pPr algn="l">
+              <a:spcAft>
+                <a:spcPts val="800"/>
+              </a:spcAft>
+            </a:pPr>
+            <a:r>
+              <a:rPr sz="1800" b="0">
+                <a:solidFill>
+                  <a:srgbClr val="4A5568"/>
+                </a:solidFill>
+                <a:latin typeface="Arial"/>
+              </a:rPr>
+              <a:t>Put this on screen. Do not skip it.</a:t>
+            </a:r>
+          </a:p>
+        </p:txBody>
+      </p:sp>
+      <p:sp>
+        <p:nvSpPr>
           <p:cNvPr id="6" name="Rectangle 5"/>
+          <p:cNvSpPr/>
+          <p:nvPr/>
+        </p:nvSpPr>
+        <p:spPr>
+          <a:xfrm>
+            <a:off x="548640" y="1371600"/>
+            <a:ext cx="11064240" cy="960120"/>
+          </a:xfrm>
+          <a:prstGeom prst="rect">
+            <a:avLst/>
+          </a:prstGeom>
+          <a:solidFill>
+            <a:srgbClr val="F0F8FF"/>
+          </a:solidFill>
+          <a:ln>
+            <a:noFill/>
+          </a:ln>
+        </p:spPr>
+        <p:style>
+          <a:lnRef idx="1">
+            <a:schemeClr val="accent1"/>
+          </a:lnRef>
+          <a:fillRef idx="3">
+            <a:schemeClr val="accent1"/>
+          </a:fillRef>
+          <a:effectRef idx="2">
+            <a:schemeClr val="accent1"/>
+          </a:effectRef>
+          <a:fontRef idx="minor">
+            <a:schemeClr val="lt1"/>
+          </a:fontRef>
+        </p:style>
+        <p:txBody>
+          <a:bodyPr rtlCol="0" anchor="ctr"/>
+          <a:lstStyle/>
+          <a:p>
+            <a:pPr algn="ctr"/>
+          </a:p>
+        </p:txBody>
+      </p:sp>
+      <p:sp>
+        <p:nvSpPr>
+          <p:cNvPr id="7" name="Rectangle 6"/>
           <p:cNvSpPr/>
           <p:nvPr/>
         </p:nvSpPr>
@@ -14264,7 +15804,7 @@
       </p:sp>
       <p:sp>
         <p:nvSpPr>
-          <p:cNvPr id="7" name="TextBox 6"/>
+          <p:cNvPr id="8" name="TextBox 7"/>
           <p:cNvSpPr txBox="1"/>
           <p:nvPr/>
         </p:nvSpPr>
@@ -14303,7 +15843,7 @@
       </p:sp>
       <p:sp>
         <p:nvSpPr>
-          <p:cNvPr id="8" name="TextBox 7"/>
+          <p:cNvPr id="9" name="TextBox 8"/>
           <p:cNvSpPr txBox="1"/>
           <p:nvPr/>
         </p:nvSpPr>
@@ -14342,7 +15882,7 @@
       </p:sp>
       <p:sp>
         <p:nvSpPr>
-          <p:cNvPr id="9" name="Rectangle 8"/>
+          <p:cNvPr id="10" name="Rectangle 9"/>
           <p:cNvSpPr/>
           <p:nvPr/>
         </p:nvSpPr>
@@ -14355,7 +15895,7 @@
             <a:avLst/>
           </a:prstGeom>
           <a:solidFill>
-            <a:srgbClr val="FFFFFF"/>
+            <a:srgbClr val="F0F8FF"/>
           </a:solidFill>
           <a:ln>
             <a:noFill/>
@@ -14385,7 +15925,7 @@
       </p:sp>
       <p:sp>
         <p:nvSpPr>
-          <p:cNvPr id="10" name="Rectangle 9"/>
+          <p:cNvPr id="11" name="Rectangle 10"/>
           <p:cNvSpPr/>
           <p:nvPr/>
         </p:nvSpPr>
@@ -14428,7 +15968,7 @@
       </p:sp>
       <p:sp>
         <p:nvSpPr>
-          <p:cNvPr id="11" name="TextBox 10"/>
+          <p:cNvPr id="12" name="TextBox 11"/>
           <p:cNvSpPr txBox="1"/>
           <p:nvPr/>
         </p:nvSpPr>
@@ -14467,7 +16007,7 @@
       </p:sp>
       <p:sp>
         <p:nvSpPr>
-          <p:cNvPr id="12" name="TextBox 11"/>
+          <p:cNvPr id="13" name="TextBox 12"/>
           <p:cNvSpPr txBox="1"/>
           <p:nvPr/>
         </p:nvSpPr>
@@ -14506,7 +16046,7 @@
       </p:sp>
       <p:sp>
         <p:nvSpPr>
-          <p:cNvPr id="13" name="Rectangle 12"/>
+          <p:cNvPr id="14" name="Rectangle 13"/>
           <p:cNvSpPr/>
           <p:nvPr/>
         </p:nvSpPr>
@@ -14519,7 +16059,7 @@
             <a:avLst/>
           </a:prstGeom>
           <a:solidFill>
-            <a:srgbClr val="FFFFFF"/>
+            <a:srgbClr val="F0F8FF"/>
           </a:solidFill>
           <a:ln>
             <a:noFill/>
@@ -14549,7 +16089,7 @@
       </p:sp>
       <p:sp>
         <p:nvSpPr>
-          <p:cNvPr id="14" name="Rectangle 13"/>
+          <p:cNvPr id="15" name="Rectangle 14"/>
           <p:cNvSpPr/>
           <p:nvPr/>
         </p:nvSpPr>
@@ -14592,7 +16132,7 @@
       </p:sp>
       <p:sp>
         <p:nvSpPr>
-          <p:cNvPr id="15" name="TextBox 14"/>
+          <p:cNvPr id="16" name="TextBox 15"/>
           <p:cNvSpPr txBox="1"/>
           <p:nvPr/>
         </p:nvSpPr>
@@ -14631,7 +16171,7 @@
       </p:sp>
       <p:sp>
         <p:nvSpPr>
-          <p:cNvPr id="16" name="TextBox 15"/>
+          <p:cNvPr id="17" name="TextBox 16"/>
           <p:cNvSpPr txBox="1"/>
           <p:nvPr/>
         </p:nvSpPr>
@@ -14670,7 +16210,7 @@
       </p:sp>
       <p:sp>
         <p:nvSpPr>
-          <p:cNvPr id="17" name="Rectangle 16"/>
+          <p:cNvPr id="18" name="Rectangle 17"/>
           <p:cNvSpPr/>
           <p:nvPr/>
         </p:nvSpPr>
@@ -14683,7 +16223,7 @@
             <a:avLst/>
           </a:prstGeom>
           <a:solidFill>
-            <a:srgbClr val="FFFFFF"/>
+            <a:srgbClr val="F0F8FF"/>
           </a:solidFill>
           <a:ln>
             <a:noFill/>
@@ -14713,7 +16253,7 @@
       </p:sp>
       <p:sp>
         <p:nvSpPr>
-          <p:cNvPr id="18" name="Rectangle 17"/>
+          <p:cNvPr id="19" name="Rectangle 18"/>
           <p:cNvSpPr/>
           <p:nvPr/>
         </p:nvSpPr>
@@ -14756,7 +16296,7 @@
       </p:sp>
       <p:sp>
         <p:nvSpPr>
-          <p:cNvPr id="19" name="TextBox 18"/>
+          <p:cNvPr id="20" name="TextBox 19"/>
           <p:cNvSpPr txBox="1"/>
           <p:nvPr/>
         </p:nvSpPr>
@@ -14795,7 +16335,7 @@
       </p:sp>
       <p:sp>
         <p:nvSpPr>
-          <p:cNvPr id="20" name="TextBox 19"/>
+          <p:cNvPr id="21" name="TextBox 20"/>
           <p:cNvSpPr txBox="1"/>
           <p:nvPr/>
         </p:nvSpPr>
@@ -14834,7 +16374,7 @@
       </p:sp>
       <p:sp>
         <p:nvSpPr>
-          <p:cNvPr id="21" name="TextBox 20"/>
+          <p:cNvPr id="22" name="TextBox 21"/>
           <p:cNvSpPr txBox="1"/>
           <p:nvPr/>
         </p:nvSpPr>
@@ -14862,18 +16402,18 @@
             <a:r>
               <a:rPr sz="1200" b="0">
                 <a:solidFill>
-                  <a:srgbClr val="5B6B7C"/>
-                </a:solidFill>
-                <a:latin typeface="Arial"/>
-              </a:rPr>
-              <a:t>50+TechBridge  ·  Free Lessons  ·  Always free</a:t>
-            </a:r>
-          </a:p>
-        </p:txBody>
-      </p:sp>
-      <p:sp>
-        <p:nvSpPr>
-          <p:cNvPr id="22" name="TextBox 21"/>
+                  <a:srgbClr val="4A5568"/>
+                </a:solidFill>
+                <a:latin typeface="Arial"/>
+              </a:rPr>
+              <a:t>50+ TechBridge  ·  Free Lessons  ·  Always free</a:t>
+            </a:r>
+          </a:p>
+        </p:txBody>
+      </p:sp>
+      <p:sp>
+        <p:nvSpPr>
+          <p:cNvPr id="23" name="TextBox 22"/>
           <p:cNvSpPr txBox="1"/>
           <p:nvPr/>
         </p:nvSpPr>
@@ -14901,7 +16441,7 @@
             <a:r>
               <a:rPr sz="1200" b="0">
                 <a:solidFill>
-                  <a:srgbClr val="5B6B7C"/>
+                  <a:srgbClr val="4A5568"/>
                 </a:solidFill>
                 <a:latin typeface="Arial"/>
               </a:rPr>

</xml_diff>